<commit_message>
Update Module 2 advanced-dax deck
Co-authored-by: Copilot <223556219+Copilot@users.noreply.github.com>
</commit_message>
<xml_diff>
--- a/modules/02-advanced-dax/assets/advanced-dax.pptx
+++ b/modules/02-advanced-dax/assets/advanced-dax.pptx
@@ -4,25 +4,28 @@
   <p:sldMasterIdLst>
     <p:sldMasterId id="2147483648" r:id="rId1"/>
   </p:sldMasterIdLst>
+  <p:notesMasterIdLst>
+    <p:notesMasterId r:id="rId18"/>
+  </p:notesMasterIdLst>
   <p:sldIdLst>
-    <p:sldId id="256" r:id="rId7"/>
-    <p:sldId id="257" r:id="rId8"/>
-    <p:sldId id="258" r:id="rId9"/>
-    <p:sldId id="259" r:id="rId10"/>
-    <p:sldId id="260" r:id="rId11"/>
-    <p:sldId id="261" r:id="rId12"/>
-    <p:sldId id="262" r:id="rId13"/>
-    <p:sldId id="263" r:id="rId14"/>
-    <p:sldId id="264" r:id="rId15"/>
-    <p:sldId id="265" r:id="rId16"/>
-    <p:sldId id="266" r:id="rId17"/>
-    <p:sldId id="267" r:id="rId18"/>
-    <p:sldId id="268" r:id="rId19"/>
-    <p:sldId id="269" r:id="rId20"/>
-    <p:sldId id="270" r:id="rId21"/>
-    <p:sldId id="271" r:id="rId22"/>
+    <p:sldId id="256" r:id="rId2"/>
+    <p:sldId id="257" r:id="rId3"/>
+    <p:sldId id="258" r:id="rId4"/>
+    <p:sldId id="259" r:id="rId5"/>
+    <p:sldId id="260" r:id="rId6"/>
+    <p:sldId id="261" r:id="rId7"/>
+    <p:sldId id="262" r:id="rId8"/>
+    <p:sldId id="263" r:id="rId9"/>
+    <p:sldId id="264" r:id="rId10"/>
+    <p:sldId id="265" r:id="rId11"/>
+    <p:sldId id="266" r:id="rId12"/>
+    <p:sldId id="267" r:id="rId13"/>
+    <p:sldId id="268" r:id="rId14"/>
+    <p:sldId id="269" r:id="rId15"/>
+    <p:sldId id="270" r:id="rId16"/>
+    <p:sldId id="271" r:id="rId17"/>
   </p:sldIdLst>
-  <p:sldSz cx="12191695" cy="6858000" type="screen4x3"/>
+  <p:sldSz cx="12192000" cy="6858000"/>
   <p:notesSz cx="6858000" cy="9144000"/>
   <p:defaultTextStyle>
     <a:defPPr>
@@ -119,11 +122,27 @@
       </a:defRPr>
     </a:lvl9pPr>
   </p:defaultTextStyle>
+  <p:extLst>
+    <p:ext uri="{EFAFB233-063F-42B5-8137-9DF3F51BA10A}">
+      <p15:sldGuideLst xmlns:p15="http://schemas.microsoft.com/office/powerpoint/2012/main">
+        <p15:guide id="1" orient="horz" pos="2160">
+          <p15:clr>
+            <a:srgbClr val="A4A3A4"/>
+          </p15:clr>
+        </p15:guide>
+        <p15:guide id="2" pos="2880">
+          <p15:clr>
+            <a:srgbClr val="A4A3A4"/>
+          </p15:clr>
+        </p15:guide>
+      </p15:sldGuideLst>
+    </p:ext>
+  </p:extLst>
 </p:presentation>
 </file>
 
 <file path=ppt/notesMasters/notesMaster1.xml><?xml version="1.0" encoding="utf-8"?>
-<p:notesMaster xmlns:a="http://schemas.openxmlformats.org/drawingml/2006/main" xmlns:p="http://schemas.openxmlformats.org/presentationml/2006/main" xmlns:r="http://schemas.openxmlformats.org/officeDocument/2006/relationships">
+<p:notesMaster xmlns:a="http://schemas.openxmlformats.org/drawingml/2006/main" xmlns:r="http://schemas.openxmlformats.org/officeDocument/2006/relationships" xmlns:p="http://schemas.openxmlformats.org/presentationml/2006/main">
   <p:cSld>
     <p:bg>
       <p:bgRef idx="1001">
@@ -144,241 +163,16 @@
           <a:chExt cx="0" cy="0"/>
         </a:xfrm>
       </p:grpSpPr>
-      <p:sp>
-        <p:nvSpPr>
-          <p:cNvPr id="2" name="Header Placeholder 1"/>
-          <p:cNvSpPr>
-            <a:spLocks noGrp="1"/>
-          </p:cNvSpPr>
-          <p:nvPr>
-            <p:ph type="hdr" sz="quarter"/>
-          </p:nvPr>
-        </p:nvSpPr>
-        <p:spPr>
-          <a:xfrm>
-            <a:off x="0" y="0"/>
-            <a:ext cx="2971800" cy="457200"/>
-          </a:xfrm>
-          <a:prstGeom prst="rect">
-            <a:avLst/>
-          </a:prstGeom>
-        </p:spPr>
-        <p:txBody>
-          <a:bodyPr vert="horz" lIns="91440" tIns="45720" rIns="91440" bIns="45720" rtlCol="0"/>
-          <a:lstStyle>
-            <a:lvl1pPr algn="l">
-              <a:defRPr sz="1200"/>
-            </a:lvl1pPr>
-          </a:lstStyle>
-          <a:p>
-            <a:endParaRPr lang="en-US"/>
-          </a:p>
-        </p:txBody>
-      </p:sp>
-      <p:sp>
-        <p:nvSpPr>
-          <p:cNvPr id="3" name="Date Placeholder 2"/>
-          <p:cNvSpPr>
-            <a:spLocks noGrp="1"/>
-          </p:cNvSpPr>
-          <p:nvPr>
-            <p:ph type="dt" idx="1"/>
-          </p:nvPr>
-        </p:nvSpPr>
-        <p:spPr>
-          <a:xfrm>
-            <a:off x="3884613" y="0"/>
-            <a:ext cx="2971800" cy="457200"/>
-          </a:xfrm>
-          <a:prstGeom prst="rect">
-            <a:avLst/>
-          </a:prstGeom>
-        </p:spPr>
-        <p:txBody>
-          <a:bodyPr vert="horz" lIns="91440" tIns="45720" rIns="91440" bIns="45720" rtlCol="0"/>
-          <a:lstStyle>
-            <a:lvl1pPr algn="r">
-              <a:defRPr sz="1200"/>
-            </a:lvl1pPr>
-          </a:lstStyle>
-          <a:p>
-            <a:fld id="{0F89C1C7-3DCD-1040-A9CF-14679D8B5DDD}" type="datetimeFigureOut">
-              <a:rPr lang="en-US" smtClean="0"/>
-              <a:t>10/17/16</a:t>
-            </a:fld>
-            <a:endParaRPr lang="en-US"/>
-          </a:p>
-        </p:txBody>
-      </p:sp>
-      <p:sp>
-        <p:nvSpPr>
-          <p:cNvPr id="4" name="Slide Image Placeholder 3"/>
-          <p:cNvSpPr>
-            <a:spLocks noGrp="1" noRot="1" noChangeAspect="1"/>
-          </p:cNvSpPr>
-          <p:nvPr>
-            <p:ph type="sldImg" idx="2"/>
-          </p:nvPr>
-        </p:nvSpPr>
-        <p:spPr>
-          <a:xfrm>
-            <a:off x="1143000" y="685800"/>
-            <a:ext cx="4572000" cy="3429000"/>
-          </a:xfrm>
-          <a:prstGeom prst="rect">
-            <a:avLst/>
-          </a:prstGeom>
-          <a:noFill/>
-          <a:ln w="12700">
-            <a:solidFill>
-              <a:prstClr val="black"/>
-            </a:solidFill>
-          </a:ln>
-        </p:spPr>
-        <p:txBody>
-          <a:bodyPr vert="horz" lIns="91440" tIns="45720" rIns="91440" bIns="45720" rtlCol="0" anchor="ctr"/>
-          <a:lstStyle/>
-          <a:p>
-            <a:endParaRPr lang="en-US"/>
-          </a:p>
-        </p:txBody>
-      </p:sp>
-      <p:sp>
-        <p:nvSpPr>
-          <p:cNvPr id="5" name="Notes Placeholder 4"/>
-          <p:cNvSpPr>
-            <a:spLocks noGrp="1"/>
-          </p:cNvSpPr>
-          <p:nvPr>
-            <p:ph type="body" sz="quarter" idx="3"/>
-          </p:nvPr>
-        </p:nvSpPr>
-        <p:spPr>
-          <a:xfrm>
-            <a:off x="685800" y="4343400"/>
-            <a:ext cx="5486400" cy="4114800"/>
-          </a:xfrm>
-          <a:prstGeom prst="rect">
-            <a:avLst/>
-          </a:prstGeom>
-        </p:spPr>
-        <p:txBody>
-          <a:bodyPr vert="horz" lIns="91440" tIns="45720" rIns="91440" bIns="45720" rtlCol="0"/>
-          <a:lstStyle/>
-          <a:p>
-            <a:pPr lvl="0"/>
-            <a:r>
-              <a:rPr lang="en-US" smtClean="0"/>
-              <a:t>Click to edit Master text styles</a:t>
-            </a:r>
-          </a:p>
-          <a:p>
-            <a:pPr lvl="1"/>
-            <a:r>
-              <a:rPr lang="en-US" smtClean="0"/>
-              <a:t>Second level</a:t>
-            </a:r>
-          </a:p>
-          <a:p>
-            <a:pPr lvl="2"/>
-            <a:r>
-              <a:rPr lang="en-US" smtClean="0"/>
-              <a:t>Third level</a:t>
-            </a:r>
-          </a:p>
-          <a:p>
-            <a:pPr lvl="3"/>
-            <a:r>
-              <a:rPr lang="en-US" smtClean="0"/>
-              <a:t>Fourth level</a:t>
-            </a:r>
-          </a:p>
-          <a:p>
-            <a:pPr lvl="4"/>
-            <a:r>
-              <a:rPr lang="en-US" smtClean="0"/>
-              <a:t>Fifth level</a:t>
-            </a:r>
-            <a:endParaRPr lang="en-US"/>
-          </a:p>
-        </p:txBody>
-      </p:sp>
-      <p:sp>
-        <p:nvSpPr>
-          <p:cNvPr id="6" name="Footer Placeholder 5"/>
-          <p:cNvSpPr>
-            <a:spLocks noGrp="1"/>
-          </p:cNvSpPr>
-          <p:nvPr>
-            <p:ph type="ftr" sz="quarter" idx="4"/>
-          </p:nvPr>
-        </p:nvSpPr>
-        <p:spPr>
-          <a:xfrm>
-            <a:off x="0" y="8685213"/>
-            <a:ext cx="2971800" cy="457200"/>
-          </a:xfrm>
-          <a:prstGeom prst="rect">
-            <a:avLst/>
-          </a:prstGeom>
-        </p:spPr>
-        <p:txBody>
-          <a:bodyPr vert="horz" lIns="91440" tIns="45720" rIns="91440" bIns="45720" rtlCol="0" anchor="b"/>
-          <a:lstStyle>
-            <a:lvl1pPr algn="l">
-              <a:defRPr sz="1200"/>
-            </a:lvl1pPr>
-          </a:lstStyle>
-          <a:p>
-            <a:endParaRPr lang="en-US"/>
-          </a:p>
-        </p:txBody>
-      </p:sp>
-      <p:sp>
-        <p:nvSpPr>
-          <p:cNvPr id="7" name="Slide Number Placeholder 6"/>
-          <p:cNvSpPr>
-            <a:spLocks noGrp="1"/>
-          </p:cNvSpPr>
-          <p:nvPr>
-            <p:ph type="sldNum" sz="quarter" idx="5"/>
-          </p:nvPr>
-        </p:nvSpPr>
-        <p:spPr>
-          <a:xfrm>
-            <a:off x="3884613" y="8685213"/>
-            <a:ext cx="2971800" cy="457200"/>
-          </a:xfrm>
-          <a:prstGeom prst="rect">
-            <a:avLst/>
-          </a:prstGeom>
-        </p:spPr>
-        <p:txBody>
-          <a:bodyPr vert="horz" lIns="91440" tIns="45720" rIns="91440" bIns="45720" rtlCol="0" anchor="b"/>
-          <a:lstStyle>
-            <a:lvl1pPr algn="r">
-              <a:defRPr sz="1200"/>
-            </a:lvl1pPr>
-          </a:lstStyle>
-          <a:p>
-            <a:fld id="{BB5E49A5-4136-284D-997B-48E1D791AD67}" type="slidenum">
-              <a:rPr lang="en-US" smtClean="0"/>
-              <a:t>‹#›</a:t>
-            </a:fld>
-            <a:endParaRPr lang="en-US"/>
-          </a:p>
-        </p:txBody>
-      </p:sp>
     </p:spTree>
     <p:extLst>
       <p:ext uri="{BB962C8B-B14F-4D97-AF65-F5344CB8AC3E}">
-        <p14:creationId xmlns:p14="http://schemas.microsoft.com/office/powerpoint/2010/main" val="2623252185"/>
+        <p14:creationId xmlns:p14="http://schemas.microsoft.com/office/powerpoint/2010/main" val="3026168138"/>
       </p:ext>
     </p:extLst>
   </p:cSld>
   <p:clrMap bg1="lt1" tx1="dk1" bg2="lt2" tx2="dk2" accent1="accent1" accent2="accent2" accent3="accent3" accent4="accent4" accent5="accent5" accent6="accent6" hlink="hlink" folHlink="folHlink"/>
   <p:notesStyle>
-    <a:lvl1pPr marL="0" algn="l" defTabSz="457200" rtl="0" eaLnBrk="1" latinLnBrk="0" hangingPunct="1">
+    <a:lvl1pPr marL="0" algn="l" defTabSz="914400" rtl="0" eaLnBrk="1" latinLnBrk="0" hangingPunct="1">
       <a:defRPr sz="1200" kern="1200">
         <a:solidFill>
           <a:schemeClr val="tx1"/>
@@ -388,7 +182,7 @@
         <a:cs typeface="+mn-cs"/>
       </a:defRPr>
     </a:lvl1pPr>
-    <a:lvl2pPr marL="457200" algn="l" defTabSz="457200" rtl="0" eaLnBrk="1" latinLnBrk="0" hangingPunct="1">
+    <a:lvl2pPr marL="457200" algn="l" defTabSz="914400" rtl="0" eaLnBrk="1" latinLnBrk="0" hangingPunct="1">
       <a:defRPr sz="1200" kern="1200">
         <a:solidFill>
           <a:schemeClr val="tx1"/>
@@ -398,7 +192,7 @@
         <a:cs typeface="+mn-cs"/>
       </a:defRPr>
     </a:lvl2pPr>
-    <a:lvl3pPr marL="914400" algn="l" defTabSz="457200" rtl="0" eaLnBrk="1" latinLnBrk="0" hangingPunct="1">
+    <a:lvl3pPr marL="914400" algn="l" defTabSz="914400" rtl="0" eaLnBrk="1" latinLnBrk="0" hangingPunct="1">
       <a:defRPr sz="1200" kern="1200">
         <a:solidFill>
           <a:schemeClr val="tx1"/>
@@ -408,7 +202,7 @@
         <a:cs typeface="+mn-cs"/>
       </a:defRPr>
     </a:lvl3pPr>
-    <a:lvl4pPr marL="1371600" algn="l" defTabSz="457200" rtl="0" eaLnBrk="1" latinLnBrk="0" hangingPunct="1">
+    <a:lvl4pPr marL="1371600" algn="l" defTabSz="914400" rtl="0" eaLnBrk="1" latinLnBrk="0" hangingPunct="1">
       <a:defRPr sz="1200" kern="1200">
         <a:solidFill>
           <a:schemeClr val="tx1"/>
@@ -418,7 +212,7 @@
         <a:cs typeface="+mn-cs"/>
       </a:defRPr>
     </a:lvl4pPr>
-    <a:lvl5pPr marL="1828800" algn="l" defTabSz="457200" rtl="0" eaLnBrk="1" latinLnBrk="0" hangingPunct="1">
+    <a:lvl5pPr marL="1828800" algn="l" defTabSz="914400" rtl="0" eaLnBrk="1" latinLnBrk="0" hangingPunct="1">
       <a:defRPr sz="1200" kern="1200">
         <a:solidFill>
           <a:schemeClr val="tx1"/>
@@ -428,7 +222,7 @@
         <a:cs typeface="+mn-cs"/>
       </a:defRPr>
     </a:lvl5pPr>
-    <a:lvl6pPr marL="2286000" algn="l" defTabSz="457200" rtl="0" eaLnBrk="1" latinLnBrk="0" hangingPunct="1">
+    <a:lvl6pPr marL="2286000" algn="l" defTabSz="914400" rtl="0" eaLnBrk="1" latinLnBrk="0" hangingPunct="1">
       <a:defRPr sz="1200" kern="1200">
         <a:solidFill>
           <a:schemeClr val="tx1"/>
@@ -438,7 +232,7 @@
         <a:cs typeface="+mn-cs"/>
       </a:defRPr>
     </a:lvl6pPr>
-    <a:lvl7pPr marL="2743200" algn="l" defTabSz="457200" rtl="0" eaLnBrk="1" latinLnBrk="0" hangingPunct="1">
+    <a:lvl7pPr marL="2743200" algn="l" defTabSz="914400" rtl="0" eaLnBrk="1" latinLnBrk="0" hangingPunct="1">
       <a:defRPr sz="1200" kern="1200">
         <a:solidFill>
           <a:schemeClr val="tx1"/>
@@ -448,7 +242,7 @@
         <a:cs typeface="+mn-cs"/>
       </a:defRPr>
     </a:lvl7pPr>
-    <a:lvl8pPr marL="3200400" algn="l" defTabSz="457200" rtl="0" eaLnBrk="1" latinLnBrk="0" hangingPunct="1">
+    <a:lvl8pPr marL="3200400" algn="l" defTabSz="914400" rtl="0" eaLnBrk="1" latinLnBrk="0" hangingPunct="1">
       <a:defRPr sz="1200" kern="1200">
         <a:solidFill>
           <a:schemeClr val="tx1"/>
@@ -458,7 +252,7 @@
         <a:cs typeface="+mn-cs"/>
       </a:defRPr>
     </a:lvl8pPr>
-    <a:lvl9pPr marL="3657600" algn="l" defTabSz="457200" rtl="0" eaLnBrk="1" latinLnBrk="0" hangingPunct="1">
+    <a:lvl9pPr marL="3657600" algn="l" defTabSz="914400" rtl="0" eaLnBrk="1" latinLnBrk="0" hangingPunct="1">
       <a:defRPr sz="1200" kern="1200">
         <a:solidFill>
           <a:schemeClr val="tx1"/>
@@ -473,7 +267,7 @@
 </file>
 
 <file path=ppt/notesSlides/notesSlide1.xml><?xml version="1.0" encoding="utf-8"?>
-<p:notes xmlns:a="http://schemas.openxmlformats.org/drawingml/2006/main" xmlns:p="http://schemas.openxmlformats.org/presentationml/2006/main" xmlns:r="http://schemas.openxmlformats.org/officeDocument/2006/relationships">
+<p:notes xmlns:a="http://schemas.openxmlformats.org/drawingml/2006/main" xmlns:r="http://schemas.openxmlformats.org/officeDocument/2006/relationships" xmlns:p="http://schemas.openxmlformats.org/presentationml/2006/main">
   <p:cSld>
     <p:spTree>
       <p:nvGrpSpPr>
@@ -493,7 +287,7 @@
         <p:nvSpPr>
           <p:cNvPr id="2" name="Slide Image Placeholder 1"/>
           <p:cNvSpPr>
-            <a:spLocks noGrp="1"/>
+            <a:spLocks noGrp="1" noRot="1" noChangeAspect="1"/>
           </p:cNvSpPr>
           <p:nvPr>
             <p:ph type="sldImg" idx="2"/>
@@ -508,7 +302,7 @@
             <a:spLocks noGrp="1"/>
           </p:cNvSpPr>
           <p:nvPr>
-            <p:ph type="body" idx="3" sz="quarter"/>
+            <p:ph type="body" sz="quarter" idx="3"/>
           </p:nvPr>
         </p:nvSpPr>
         <p:spPr/>
@@ -544,7 +338,7 @@
             <a:spLocks noGrp="1"/>
           </p:cNvSpPr>
           <p:nvPr>
-            <p:ph type="sldNum" idx="5" sz="quarter"/>
+            <p:ph type="sldNum" sz="quarter" idx="5"/>
           </p:nvPr>
         </p:nvSpPr>
         <p:spPr/>
@@ -558,7 +352,7 @@
 </file>
 
 <file path=ppt/notesSlides/notesSlide10.xml><?xml version="1.0" encoding="utf-8"?>
-<p:notes xmlns:a="http://schemas.openxmlformats.org/drawingml/2006/main" xmlns:p="http://schemas.openxmlformats.org/presentationml/2006/main" xmlns:r="http://schemas.openxmlformats.org/officeDocument/2006/relationships">
+<p:notes xmlns:a="http://schemas.openxmlformats.org/drawingml/2006/main" xmlns:r="http://schemas.openxmlformats.org/officeDocument/2006/relationships" xmlns:p="http://schemas.openxmlformats.org/presentationml/2006/main">
   <p:cSld>
     <p:spTree>
       <p:nvGrpSpPr>
@@ -578,7 +372,7 @@
         <p:nvSpPr>
           <p:cNvPr id="2" name="Slide Image Placeholder 1"/>
           <p:cNvSpPr>
-            <a:spLocks noGrp="1"/>
+            <a:spLocks noGrp="1" noRot="1" noChangeAspect="1"/>
           </p:cNvSpPr>
           <p:nvPr>
             <p:ph type="sldImg" idx="2"/>
@@ -593,7 +387,7 @@
             <a:spLocks noGrp="1"/>
           </p:cNvSpPr>
           <p:nvPr>
-            <p:ph type="body" idx="3" sz="quarter"/>
+            <p:ph type="body" sz="quarter" idx="3"/>
           </p:nvPr>
         </p:nvSpPr>
         <p:spPr/>
@@ -649,7 +443,7 @@
             <a:spLocks noGrp="1"/>
           </p:cNvSpPr>
           <p:nvPr>
-            <p:ph type="sldNum" idx="5" sz="quarter"/>
+            <p:ph type="sldNum" sz="quarter" idx="5"/>
           </p:nvPr>
         </p:nvSpPr>
         <p:spPr/>
@@ -663,7 +457,7 @@
 </file>
 
 <file path=ppt/notesSlides/notesSlide11.xml><?xml version="1.0" encoding="utf-8"?>
-<p:notes xmlns:a="http://schemas.openxmlformats.org/drawingml/2006/main" xmlns:p="http://schemas.openxmlformats.org/presentationml/2006/main" xmlns:r="http://schemas.openxmlformats.org/officeDocument/2006/relationships">
+<p:notes xmlns:a="http://schemas.openxmlformats.org/drawingml/2006/main" xmlns:r="http://schemas.openxmlformats.org/officeDocument/2006/relationships" xmlns:p="http://schemas.openxmlformats.org/presentationml/2006/main">
   <p:cSld>
     <p:spTree>
       <p:nvGrpSpPr>
@@ -683,7 +477,7 @@
         <p:nvSpPr>
           <p:cNvPr id="2" name="Slide Image Placeholder 1"/>
           <p:cNvSpPr>
-            <a:spLocks noGrp="1"/>
+            <a:spLocks noGrp="1" noRot="1" noChangeAspect="1"/>
           </p:cNvSpPr>
           <p:nvPr>
             <p:ph type="sldImg" idx="2"/>
@@ -698,7 +492,7 @@
             <a:spLocks noGrp="1"/>
           </p:cNvSpPr>
           <p:nvPr>
-            <p:ph type="body" idx="3" sz="quarter"/>
+            <p:ph type="body" sz="quarter" idx="3"/>
           </p:nvPr>
         </p:nvSpPr>
         <p:spPr/>
@@ -754,7 +548,7 @@
             <a:spLocks noGrp="1"/>
           </p:cNvSpPr>
           <p:nvPr>
-            <p:ph type="sldNum" idx="5" sz="quarter"/>
+            <p:ph type="sldNum" sz="quarter" idx="5"/>
           </p:nvPr>
         </p:nvSpPr>
         <p:spPr/>
@@ -768,7 +562,7 @@
 </file>
 
 <file path=ppt/notesSlides/notesSlide12.xml><?xml version="1.0" encoding="utf-8"?>
-<p:notes xmlns:a="http://schemas.openxmlformats.org/drawingml/2006/main" xmlns:p="http://schemas.openxmlformats.org/presentationml/2006/main" xmlns:r="http://schemas.openxmlformats.org/officeDocument/2006/relationships">
+<p:notes xmlns:a="http://schemas.openxmlformats.org/drawingml/2006/main" xmlns:r="http://schemas.openxmlformats.org/officeDocument/2006/relationships" xmlns:p="http://schemas.openxmlformats.org/presentationml/2006/main">
   <p:cSld>
     <p:spTree>
       <p:nvGrpSpPr>
@@ -788,7 +582,7 @@
         <p:nvSpPr>
           <p:cNvPr id="2" name="Slide Image Placeholder 1"/>
           <p:cNvSpPr>
-            <a:spLocks noGrp="1"/>
+            <a:spLocks noGrp="1" noRot="1" noChangeAspect="1"/>
           </p:cNvSpPr>
           <p:nvPr>
             <p:ph type="sldImg" idx="2"/>
@@ -803,7 +597,7 @@
             <a:spLocks noGrp="1"/>
           </p:cNvSpPr>
           <p:nvPr>
-            <p:ph type="body" idx="3" sz="quarter"/>
+            <p:ph type="body" sz="quarter" idx="3"/>
           </p:nvPr>
         </p:nvSpPr>
         <p:spPr/>
@@ -859,7 +653,7 @@
             <a:spLocks noGrp="1"/>
           </p:cNvSpPr>
           <p:nvPr>
-            <p:ph type="sldNum" idx="5" sz="quarter"/>
+            <p:ph type="sldNum" sz="quarter" idx="5"/>
           </p:nvPr>
         </p:nvSpPr>
         <p:spPr/>
@@ -873,7 +667,7 @@
 </file>
 
 <file path=ppt/notesSlides/notesSlide13.xml><?xml version="1.0" encoding="utf-8"?>
-<p:notes xmlns:a="http://schemas.openxmlformats.org/drawingml/2006/main" xmlns:p="http://schemas.openxmlformats.org/presentationml/2006/main" xmlns:r="http://schemas.openxmlformats.org/officeDocument/2006/relationships">
+<p:notes xmlns:a="http://schemas.openxmlformats.org/drawingml/2006/main" xmlns:r="http://schemas.openxmlformats.org/officeDocument/2006/relationships" xmlns:p="http://schemas.openxmlformats.org/presentationml/2006/main">
   <p:cSld>
     <p:spTree>
       <p:nvGrpSpPr>
@@ -893,7 +687,7 @@
         <p:nvSpPr>
           <p:cNvPr id="2" name="Slide Image Placeholder 1"/>
           <p:cNvSpPr>
-            <a:spLocks noGrp="1"/>
+            <a:spLocks noGrp="1" noRot="1" noChangeAspect="1"/>
           </p:cNvSpPr>
           <p:nvPr>
             <p:ph type="sldImg" idx="2"/>
@@ -908,7 +702,7 @@
             <a:spLocks noGrp="1"/>
           </p:cNvSpPr>
           <p:nvPr>
-            <p:ph type="body" idx="3" sz="quarter"/>
+            <p:ph type="body" sz="quarter" idx="3"/>
           </p:nvPr>
         </p:nvSpPr>
         <p:spPr/>
@@ -964,7 +758,7 @@
             <a:spLocks noGrp="1"/>
           </p:cNvSpPr>
           <p:nvPr>
-            <p:ph type="sldNum" idx="5" sz="quarter"/>
+            <p:ph type="sldNum" sz="quarter" idx="5"/>
           </p:nvPr>
         </p:nvSpPr>
         <p:spPr/>
@@ -978,7 +772,7 @@
 </file>
 
 <file path=ppt/notesSlides/notesSlide14.xml><?xml version="1.0" encoding="utf-8"?>
-<p:notes xmlns:a="http://schemas.openxmlformats.org/drawingml/2006/main" xmlns:p="http://schemas.openxmlformats.org/presentationml/2006/main" xmlns:r="http://schemas.openxmlformats.org/officeDocument/2006/relationships">
+<p:notes xmlns:a="http://schemas.openxmlformats.org/drawingml/2006/main" xmlns:r="http://schemas.openxmlformats.org/officeDocument/2006/relationships" xmlns:p="http://schemas.openxmlformats.org/presentationml/2006/main">
   <p:cSld>
     <p:spTree>
       <p:nvGrpSpPr>
@@ -998,7 +792,7 @@
         <p:nvSpPr>
           <p:cNvPr id="2" name="Slide Image Placeholder 1"/>
           <p:cNvSpPr>
-            <a:spLocks noGrp="1"/>
+            <a:spLocks noGrp="1" noRot="1" noChangeAspect="1"/>
           </p:cNvSpPr>
           <p:nvPr>
             <p:ph type="sldImg" idx="2"/>
@@ -1013,7 +807,7 @@
             <a:spLocks noGrp="1"/>
           </p:cNvSpPr>
           <p:nvPr>
-            <p:ph type="body" idx="3" sz="quarter"/>
+            <p:ph type="body" sz="quarter" idx="3"/>
           </p:nvPr>
         </p:nvSpPr>
         <p:spPr/>
@@ -1069,7 +863,7 @@
             <a:spLocks noGrp="1"/>
           </p:cNvSpPr>
           <p:nvPr>
-            <p:ph type="sldNum" idx="5" sz="quarter"/>
+            <p:ph type="sldNum" sz="quarter" idx="5"/>
           </p:nvPr>
         </p:nvSpPr>
         <p:spPr/>
@@ -1083,7 +877,7 @@
 </file>
 
 <file path=ppt/notesSlides/notesSlide15.xml><?xml version="1.0" encoding="utf-8"?>
-<p:notes xmlns:a="http://schemas.openxmlformats.org/drawingml/2006/main" xmlns:p="http://schemas.openxmlformats.org/presentationml/2006/main" xmlns:r="http://schemas.openxmlformats.org/officeDocument/2006/relationships">
+<p:notes xmlns:a="http://schemas.openxmlformats.org/drawingml/2006/main" xmlns:r="http://schemas.openxmlformats.org/officeDocument/2006/relationships" xmlns:p="http://schemas.openxmlformats.org/presentationml/2006/main">
   <p:cSld>
     <p:spTree>
       <p:nvGrpSpPr>
@@ -1103,7 +897,7 @@
         <p:nvSpPr>
           <p:cNvPr id="2" name="Slide Image Placeholder 1"/>
           <p:cNvSpPr>
-            <a:spLocks noGrp="1"/>
+            <a:spLocks noGrp="1" noRot="1" noChangeAspect="1"/>
           </p:cNvSpPr>
           <p:nvPr>
             <p:ph type="sldImg" idx="2"/>
@@ -1118,7 +912,7 @@
             <a:spLocks noGrp="1"/>
           </p:cNvSpPr>
           <p:nvPr>
-            <p:ph type="body" idx="3" sz="quarter"/>
+            <p:ph type="body" sz="quarter" idx="3"/>
           </p:nvPr>
         </p:nvSpPr>
         <p:spPr/>
@@ -1149,7 +943,7 @@
             <a:spLocks noGrp="1"/>
           </p:cNvSpPr>
           <p:nvPr>
-            <p:ph type="sldNum" idx="5" sz="quarter"/>
+            <p:ph type="sldNum" sz="quarter" idx="5"/>
           </p:nvPr>
         </p:nvSpPr>
         <p:spPr/>
@@ -1163,7 +957,7 @@
 </file>
 
 <file path=ppt/notesSlides/notesSlide16.xml><?xml version="1.0" encoding="utf-8"?>
-<p:notes xmlns:a="http://schemas.openxmlformats.org/drawingml/2006/main" xmlns:p="http://schemas.openxmlformats.org/presentationml/2006/main" xmlns:r="http://schemas.openxmlformats.org/officeDocument/2006/relationships">
+<p:notes xmlns:a="http://schemas.openxmlformats.org/drawingml/2006/main" xmlns:r="http://schemas.openxmlformats.org/officeDocument/2006/relationships" xmlns:p="http://schemas.openxmlformats.org/presentationml/2006/main">
   <p:cSld>
     <p:spTree>
       <p:nvGrpSpPr>
@@ -1183,7 +977,7 @@
         <p:nvSpPr>
           <p:cNvPr id="2" name="Slide Image Placeholder 1"/>
           <p:cNvSpPr>
-            <a:spLocks noGrp="1"/>
+            <a:spLocks noGrp="1" noRot="1" noChangeAspect="1"/>
           </p:cNvSpPr>
           <p:nvPr>
             <p:ph type="sldImg" idx="2"/>
@@ -1198,7 +992,7 @@
             <a:spLocks noGrp="1"/>
           </p:cNvSpPr>
           <p:nvPr>
-            <p:ph type="body" idx="3" sz="quarter"/>
+            <p:ph type="body" sz="quarter" idx="3"/>
           </p:nvPr>
         </p:nvSpPr>
         <p:spPr/>
@@ -1229,7 +1023,7 @@
             <a:spLocks noGrp="1"/>
           </p:cNvSpPr>
           <p:nvPr>
-            <p:ph type="sldNum" idx="5" sz="quarter"/>
+            <p:ph type="sldNum" sz="quarter" idx="5"/>
           </p:nvPr>
         </p:nvSpPr>
         <p:spPr/>
@@ -1243,7 +1037,7 @@
 </file>
 
 <file path=ppt/notesSlides/notesSlide2.xml><?xml version="1.0" encoding="utf-8"?>
-<p:notes xmlns:a="http://schemas.openxmlformats.org/drawingml/2006/main" xmlns:p="http://schemas.openxmlformats.org/presentationml/2006/main" xmlns:r="http://schemas.openxmlformats.org/officeDocument/2006/relationships">
+<p:notes xmlns:a="http://schemas.openxmlformats.org/drawingml/2006/main" xmlns:r="http://schemas.openxmlformats.org/officeDocument/2006/relationships" xmlns:p="http://schemas.openxmlformats.org/presentationml/2006/main">
   <p:cSld>
     <p:spTree>
       <p:nvGrpSpPr>
@@ -1263,7 +1057,7 @@
         <p:nvSpPr>
           <p:cNvPr id="2" name="Slide Image Placeholder 1"/>
           <p:cNvSpPr>
-            <a:spLocks noGrp="1"/>
+            <a:spLocks noGrp="1" noRot="1" noChangeAspect="1"/>
           </p:cNvSpPr>
           <p:nvPr>
             <p:ph type="sldImg" idx="2"/>
@@ -1278,7 +1072,7 @@
             <a:spLocks noGrp="1"/>
           </p:cNvSpPr>
           <p:nvPr>
-            <p:ph type="body" idx="3" sz="quarter"/>
+            <p:ph type="body" sz="quarter" idx="3"/>
           </p:nvPr>
         </p:nvSpPr>
         <p:spPr/>
@@ -1314,7 +1108,7 @@
             <a:spLocks noGrp="1"/>
           </p:cNvSpPr>
           <p:nvPr>
-            <p:ph type="sldNum" idx="5" sz="quarter"/>
+            <p:ph type="sldNum" sz="quarter" idx="5"/>
           </p:nvPr>
         </p:nvSpPr>
         <p:spPr/>
@@ -1328,7 +1122,7 @@
 </file>
 
 <file path=ppt/notesSlides/notesSlide3.xml><?xml version="1.0" encoding="utf-8"?>
-<p:notes xmlns:a="http://schemas.openxmlformats.org/drawingml/2006/main" xmlns:p="http://schemas.openxmlformats.org/presentationml/2006/main" xmlns:r="http://schemas.openxmlformats.org/officeDocument/2006/relationships">
+<p:notes xmlns:a="http://schemas.openxmlformats.org/drawingml/2006/main" xmlns:r="http://schemas.openxmlformats.org/officeDocument/2006/relationships" xmlns:p="http://schemas.openxmlformats.org/presentationml/2006/main">
   <p:cSld>
     <p:spTree>
       <p:nvGrpSpPr>
@@ -1348,7 +1142,7 @@
         <p:nvSpPr>
           <p:cNvPr id="2" name="Slide Image Placeholder 1"/>
           <p:cNvSpPr>
-            <a:spLocks noGrp="1"/>
+            <a:spLocks noGrp="1" noRot="1" noChangeAspect="1"/>
           </p:cNvSpPr>
           <p:nvPr>
             <p:ph type="sldImg" idx="2"/>
@@ -1363,7 +1157,7 @@
             <a:spLocks noGrp="1"/>
           </p:cNvSpPr>
           <p:nvPr>
-            <p:ph type="body" idx="3" sz="quarter"/>
+            <p:ph type="body" sz="quarter" idx="3"/>
           </p:nvPr>
         </p:nvSpPr>
         <p:spPr/>
@@ -1419,7 +1213,7 @@
             <a:spLocks noGrp="1"/>
           </p:cNvSpPr>
           <p:nvPr>
-            <p:ph type="sldNum" idx="5" sz="quarter"/>
+            <p:ph type="sldNum" sz="quarter" idx="5"/>
           </p:nvPr>
         </p:nvSpPr>
         <p:spPr/>
@@ -1433,7 +1227,7 @@
 </file>
 
 <file path=ppt/notesSlides/notesSlide4.xml><?xml version="1.0" encoding="utf-8"?>
-<p:notes xmlns:a="http://schemas.openxmlformats.org/drawingml/2006/main" xmlns:p="http://schemas.openxmlformats.org/presentationml/2006/main" xmlns:r="http://schemas.openxmlformats.org/officeDocument/2006/relationships">
+<p:notes xmlns:a="http://schemas.openxmlformats.org/drawingml/2006/main" xmlns:r="http://schemas.openxmlformats.org/officeDocument/2006/relationships" xmlns:p="http://schemas.openxmlformats.org/presentationml/2006/main">
   <p:cSld>
     <p:spTree>
       <p:nvGrpSpPr>
@@ -1453,7 +1247,7 @@
         <p:nvSpPr>
           <p:cNvPr id="2" name="Slide Image Placeholder 1"/>
           <p:cNvSpPr>
-            <a:spLocks noGrp="1"/>
+            <a:spLocks noGrp="1" noRot="1" noChangeAspect="1"/>
           </p:cNvSpPr>
           <p:nvPr>
             <p:ph type="sldImg" idx="2"/>
@@ -1468,7 +1262,7 @@
             <a:spLocks noGrp="1"/>
           </p:cNvSpPr>
           <p:nvPr>
-            <p:ph type="body" idx="3" sz="quarter"/>
+            <p:ph type="body" sz="quarter" idx="3"/>
           </p:nvPr>
         </p:nvSpPr>
         <p:spPr/>
@@ -1524,7 +1318,7 @@
             <a:spLocks noGrp="1"/>
           </p:cNvSpPr>
           <p:nvPr>
-            <p:ph type="sldNum" idx="5" sz="quarter"/>
+            <p:ph type="sldNum" sz="quarter" idx="5"/>
           </p:nvPr>
         </p:nvSpPr>
         <p:spPr/>
@@ -1538,7 +1332,7 @@
 </file>
 
 <file path=ppt/notesSlides/notesSlide5.xml><?xml version="1.0" encoding="utf-8"?>
-<p:notes xmlns:a="http://schemas.openxmlformats.org/drawingml/2006/main" xmlns:p="http://schemas.openxmlformats.org/presentationml/2006/main" xmlns:r="http://schemas.openxmlformats.org/officeDocument/2006/relationships">
+<p:notes xmlns:a="http://schemas.openxmlformats.org/drawingml/2006/main" xmlns:r="http://schemas.openxmlformats.org/officeDocument/2006/relationships" xmlns:p="http://schemas.openxmlformats.org/presentationml/2006/main">
   <p:cSld>
     <p:spTree>
       <p:nvGrpSpPr>
@@ -1558,7 +1352,7 @@
         <p:nvSpPr>
           <p:cNvPr id="2" name="Slide Image Placeholder 1"/>
           <p:cNvSpPr>
-            <a:spLocks noGrp="1"/>
+            <a:spLocks noGrp="1" noRot="1" noChangeAspect="1"/>
           </p:cNvSpPr>
           <p:nvPr>
             <p:ph type="sldImg" idx="2"/>
@@ -1573,7 +1367,7 @@
             <a:spLocks noGrp="1"/>
           </p:cNvSpPr>
           <p:nvPr>
-            <p:ph type="body" idx="3" sz="quarter"/>
+            <p:ph type="body" sz="quarter" idx="3"/>
           </p:nvPr>
         </p:nvSpPr>
         <p:spPr/>
@@ -1629,7 +1423,7 @@
             <a:spLocks noGrp="1"/>
           </p:cNvSpPr>
           <p:nvPr>
-            <p:ph type="sldNum" idx="5" sz="quarter"/>
+            <p:ph type="sldNum" sz="quarter" idx="5"/>
           </p:nvPr>
         </p:nvSpPr>
         <p:spPr/>
@@ -1643,7 +1437,7 @@
 </file>
 
 <file path=ppt/notesSlides/notesSlide6.xml><?xml version="1.0" encoding="utf-8"?>
-<p:notes xmlns:a="http://schemas.openxmlformats.org/drawingml/2006/main" xmlns:p="http://schemas.openxmlformats.org/presentationml/2006/main" xmlns:r="http://schemas.openxmlformats.org/officeDocument/2006/relationships">
+<p:notes xmlns:a="http://schemas.openxmlformats.org/drawingml/2006/main" xmlns:r="http://schemas.openxmlformats.org/officeDocument/2006/relationships" xmlns:p="http://schemas.openxmlformats.org/presentationml/2006/main">
   <p:cSld>
     <p:spTree>
       <p:nvGrpSpPr>
@@ -1663,7 +1457,7 @@
         <p:nvSpPr>
           <p:cNvPr id="2" name="Slide Image Placeholder 1"/>
           <p:cNvSpPr>
-            <a:spLocks noGrp="1"/>
+            <a:spLocks noGrp="1" noRot="1" noChangeAspect="1"/>
           </p:cNvSpPr>
           <p:nvPr>
             <p:ph type="sldImg" idx="2"/>
@@ -1678,7 +1472,7 @@
             <a:spLocks noGrp="1"/>
           </p:cNvSpPr>
           <p:nvPr>
-            <p:ph type="body" idx="3" sz="quarter"/>
+            <p:ph type="body" sz="quarter" idx="3"/>
           </p:nvPr>
         </p:nvSpPr>
         <p:spPr/>
@@ -1734,7 +1528,7 @@
             <a:spLocks noGrp="1"/>
           </p:cNvSpPr>
           <p:nvPr>
-            <p:ph type="sldNum" idx="5" sz="quarter"/>
+            <p:ph type="sldNum" sz="quarter" idx="5"/>
           </p:nvPr>
         </p:nvSpPr>
         <p:spPr/>
@@ -1748,7 +1542,7 @@
 </file>
 
 <file path=ppt/notesSlides/notesSlide7.xml><?xml version="1.0" encoding="utf-8"?>
-<p:notes xmlns:a="http://schemas.openxmlformats.org/drawingml/2006/main" xmlns:p="http://schemas.openxmlformats.org/presentationml/2006/main" xmlns:r="http://schemas.openxmlformats.org/officeDocument/2006/relationships">
+<p:notes xmlns:a="http://schemas.openxmlformats.org/drawingml/2006/main" xmlns:r="http://schemas.openxmlformats.org/officeDocument/2006/relationships" xmlns:p="http://schemas.openxmlformats.org/presentationml/2006/main">
   <p:cSld>
     <p:spTree>
       <p:nvGrpSpPr>
@@ -1768,7 +1562,7 @@
         <p:nvSpPr>
           <p:cNvPr id="2" name="Slide Image Placeholder 1"/>
           <p:cNvSpPr>
-            <a:spLocks noGrp="1"/>
+            <a:spLocks noGrp="1" noRot="1" noChangeAspect="1"/>
           </p:cNvSpPr>
           <p:nvPr>
             <p:ph type="sldImg" idx="2"/>
@@ -1783,7 +1577,7 @@
             <a:spLocks noGrp="1"/>
           </p:cNvSpPr>
           <p:nvPr>
-            <p:ph type="body" idx="3" sz="quarter"/>
+            <p:ph type="body" sz="quarter" idx="3"/>
           </p:nvPr>
         </p:nvSpPr>
         <p:spPr/>
@@ -1839,7 +1633,7 @@
             <a:spLocks noGrp="1"/>
           </p:cNvSpPr>
           <p:nvPr>
-            <p:ph type="sldNum" idx="5" sz="quarter"/>
+            <p:ph type="sldNum" sz="quarter" idx="5"/>
           </p:nvPr>
         </p:nvSpPr>
         <p:spPr/>
@@ -1853,7 +1647,7 @@
 </file>
 
 <file path=ppt/notesSlides/notesSlide8.xml><?xml version="1.0" encoding="utf-8"?>
-<p:notes xmlns:a="http://schemas.openxmlformats.org/drawingml/2006/main" xmlns:p="http://schemas.openxmlformats.org/presentationml/2006/main" xmlns:r="http://schemas.openxmlformats.org/officeDocument/2006/relationships">
+<p:notes xmlns:a="http://schemas.openxmlformats.org/drawingml/2006/main" xmlns:r="http://schemas.openxmlformats.org/officeDocument/2006/relationships" xmlns:p="http://schemas.openxmlformats.org/presentationml/2006/main">
   <p:cSld>
     <p:spTree>
       <p:nvGrpSpPr>
@@ -1873,7 +1667,7 @@
         <p:nvSpPr>
           <p:cNvPr id="2" name="Slide Image Placeholder 1"/>
           <p:cNvSpPr>
-            <a:spLocks noGrp="1"/>
+            <a:spLocks noGrp="1" noRot="1" noChangeAspect="1"/>
           </p:cNvSpPr>
           <p:nvPr>
             <p:ph type="sldImg" idx="2"/>
@@ -1888,7 +1682,7 @@
             <a:spLocks noGrp="1"/>
           </p:cNvSpPr>
           <p:nvPr>
-            <p:ph type="body" idx="3" sz="quarter"/>
+            <p:ph type="body" sz="quarter" idx="3"/>
           </p:nvPr>
         </p:nvSpPr>
         <p:spPr/>
@@ -1944,7 +1738,7 @@
             <a:spLocks noGrp="1"/>
           </p:cNvSpPr>
           <p:nvPr>
-            <p:ph type="sldNum" idx="5" sz="quarter"/>
+            <p:ph type="sldNum" sz="quarter" idx="5"/>
           </p:nvPr>
         </p:nvSpPr>
         <p:spPr/>
@@ -1958,7 +1752,7 @@
 </file>
 
 <file path=ppt/notesSlides/notesSlide9.xml><?xml version="1.0" encoding="utf-8"?>
-<p:notes xmlns:a="http://schemas.openxmlformats.org/drawingml/2006/main" xmlns:p="http://schemas.openxmlformats.org/presentationml/2006/main" xmlns:r="http://schemas.openxmlformats.org/officeDocument/2006/relationships">
+<p:notes xmlns:a="http://schemas.openxmlformats.org/drawingml/2006/main" xmlns:r="http://schemas.openxmlformats.org/officeDocument/2006/relationships" xmlns:p="http://schemas.openxmlformats.org/presentationml/2006/main">
   <p:cSld>
     <p:spTree>
       <p:nvGrpSpPr>
@@ -1978,7 +1772,7 @@
         <p:nvSpPr>
           <p:cNvPr id="2" name="Slide Image Placeholder 1"/>
           <p:cNvSpPr>
-            <a:spLocks noGrp="1"/>
+            <a:spLocks noGrp="1" noRot="1" noChangeAspect="1"/>
           </p:cNvSpPr>
           <p:nvPr>
             <p:ph type="sldImg" idx="2"/>
@@ -1993,7 +1787,7 @@
             <a:spLocks noGrp="1"/>
           </p:cNvSpPr>
           <p:nvPr>
-            <p:ph type="body" idx="3" sz="quarter"/>
+            <p:ph type="body" sz="quarter" idx="3"/>
           </p:nvPr>
         </p:nvSpPr>
         <p:spPr/>
@@ -2049,7 +1843,7 @@
             <a:spLocks noGrp="1"/>
           </p:cNvSpPr>
           <p:nvPr>
-            <p:ph type="sldNum" idx="5" sz="quarter"/>
+            <p:ph type="sldNum" sz="quarter" idx="5"/>
           </p:nvPr>
         </p:nvSpPr>
         <p:spPr/>
@@ -2100,10 +1894,9 @@
           <a:lstStyle/>
           <a:p>
             <a:r>
-              <a:rPr lang="en-US" smtClean="0"/>
+              <a:rPr lang="en-US"/>
               <a:t>Click to edit Master title style</a:t>
             </a:r>
-            <a:endParaRPr lang="en-US"/>
           </a:p>
         </p:txBody>
       </p:sp>
@@ -2219,10 +2012,9 @@
           </a:lstStyle>
           <a:p>
             <a:r>
-              <a:rPr lang="en-US" smtClean="0"/>
+              <a:rPr lang="en-US"/>
               <a:t>Click to edit Master subtitle style</a:t>
             </a:r>
-            <a:endParaRPr lang="en-US"/>
           </a:p>
         </p:txBody>
       </p:sp>
@@ -2243,7 +2035,7 @@
           <a:p>
             <a:fld id="{5BCAD085-E8A6-8845-BD4E-CB4CCA059FC4}" type="datetimeFigureOut">
               <a:rPr lang="en-US" smtClean="0"/>
-              <a:t>1/27/13</a:t>
+              <a:t>8/13/2026</a:t>
             </a:fld>
             <a:endParaRPr lang="en-US"/>
           </a:p>
@@ -2337,10 +2129,9 @@
           <a:lstStyle/>
           <a:p>
             <a:r>
-              <a:rPr lang="en-US" smtClean="0"/>
+              <a:rPr lang="en-US"/>
               <a:t>Click to edit Master title style</a:t>
             </a:r>
-            <a:endParaRPr lang="en-US"/>
           </a:p>
         </p:txBody>
       </p:sp>
@@ -2361,38 +2152,37 @@
           <a:p>
             <a:pPr lvl="0"/>
             <a:r>
-              <a:rPr lang="en-US" smtClean="0"/>
+              <a:rPr lang="en-US"/>
               <a:t>Click to edit Master text styles</a:t>
             </a:r>
           </a:p>
           <a:p>
             <a:pPr lvl="1"/>
             <a:r>
-              <a:rPr lang="en-US" smtClean="0"/>
+              <a:rPr lang="en-US"/>
               <a:t>Second level</a:t>
             </a:r>
           </a:p>
           <a:p>
             <a:pPr lvl="2"/>
             <a:r>
-              <a:rPr lang="en-US" smtClean="0"/>
+              <a:rPr lang="en-US"/>
               <a:t>Third level</a:t>
             </a:r>
           </a:p>
           <a:p>
             <a:pPr lvl="3"/>
             <a:r>
-              <a:rPr lang="en-US" smtClean="0"/>
+              <a:rPr lang="en-US"/>
               <a:t>Fourth level</a:t>
             </a:r>
           </a:p>
           <a:p>
             <a:pPr lvl="4"/>
             <a:r>
-              <a:rPr lang="en-US" smtClean="0"/>
+              <a:rPr lang="en-US"/>
               <a:t>Fifth level</a:t>
             </a:r>
-            <a:endParaRPr lang="en-US"/>
           </a:p>
         </p:txBody>
       </p:sp>
@@ -2413,7 +2203,7 @@
           <a:p>
             <a:fld id="{5BCAD085-E8A6-8845-BD4E-CB4CCA059FC4}" type="datetimeFigureOut">
               <a:rPr lang="en-US" smtClean="0"/>
-              <a:t>1/27/13</a:t>
+              <a:t>8/13/2026</a:t>
             </a:fld>
             <a:endParaRPr lang="en-US"/>
           </a:p>
@@ -2512,10 +2302,9 @@
           <a:lstStyle/>
           <a:p>
             <a:r>
-              <a:rPr lang="en-US" smtClean="0"/>
+              <a:rPr lang="en-US"/>
               <a:t>Click to edit Master title style</a:t>
             </a:r>
-            <a:endParaRPr lang="en-US"/>
           </a:p>
         </p:txBody>
       </p:sp>
@@ -2541,38 +2330,37 @@
           <a:p>
             <a:pPr lvl="0"/>
             <a:r>
-              <a:rPr lang="en-US" smtClean="0"/>
+              <a:rPr lang="en-US"/>
               <a:t>Click to edit Master text styles</a:t>
             </a:r>
           </a:p>
           <a:p>
             <a:pPr lvl="1"/>
             <a:r>
-              <a:rPr lang="en-US" smtClean="0"/>
+              <a:rPr lang="en-US"/>
               <a:t>Second level</a:t>
             </a:r>
           </a:p>
           <a:p>
             <a:pPr lvl="2"/>
             <a:r>
-              <a:rPr lang="en-US" smtClean="0"/>
+              <a:rPr lang="en-US"/>
               <a:t>Third level</a:t>
             </a:r>
           </a:p>
           <a:p>
             <a:pPr lvl="3"/>
             <a:r>
-              <a:rPr lang="en-US" smtClean="0"/>
+              <a:rPr lang="en-US"/>
               <a:t>Fourth level</a:t>
             </a:r>
           </a:p>
           <a:p>
             <a:pPr lvl="4"/>
             <a:r>
-              <a:rPr lang="en-US" smtClean="0"/>
+              <a:rPr lang="en-US"/>
               <a:t>Fifth level</a:t>
             </a:r>
-            <a:endParaRPr lang="en-US"/>
           </a:p>
         </p:txBody>
       </p:sp>
@@ -2593,7 +2381,7 @@
           <a:p>
             <a:fld id="{5BCAD085-E8A6-8845-BD4E-CB4CCA059FC4}" type="datetimeFigureOut">
               <a:rPr lang="en-US" smtClean="0"/>
-              <a:t>1/27/13</a:t>
+              <a:t>8/13/2026</a:t>
             </a:fld>
             <a:endParaRPr lang="en-US"/>
           </a:p>
@@ -2687,10 +2475,9 @@
           <a:lstStyle/>
           <a:p>
             <a:r>
-              <a:rPr lang="en-US" smtClean="0"/>
+              <a:rPr lang="en-US"/>
               <a:t>Click to edit Master title style</a:t>
             </a:r>
-            <a:endParaRPr lang="en-US"/>
           </a:p>
         </p:txBody>
       </p:sp>
@@ -2711,38 +2498,37 @@
           <a:p>
             <a:pPr lvl="0"/>
             <a:r>
-              <a:rPr lang="en-US" smtClean="0"/>
+              <a:rPr lang="en-US"/>
               <a:t>Click to edit Master text styles</a:t>
             </a:r>
           </a:p>
           <a:p>
             <a:pPr lvl="1"/>
             <a:r>
-              <a:rPr lang="en-US" smtClean="0"/>
+              <a:rPr lang="en-US"/>
               <a:t>Second level</a:t>
             </a:r>
           </a:p>
           <a:p>
             <a:pPr lvl="2"/>
             <a:r>
-              <a:rPr lang="en-US" smtClean="0"/>
+              <a:rPr lang="en-US"/>
               <a:t>Third level</a:t>
             </a:r>
           </a:p>
           <a:p>
             <a:pPr lvl="3"/>
             <a:r>
-              <a:rPr lang="en-US" smtClean="0"/>
+              <a:rPr lang="en-US"/>
               <a:t>Fourth level</a:t>
             </a:r>
           </a:p>
           <a:p>
             <a:pPr lvl="4"/>
             <a:r>
-              <a:rPr lang="en-US" smtClean="0"/>
+              <a:rPr lang="en-US"/>
               <a:t>Fifth level</a:t>
             </a:r>
-            <a:endParaRPr lang="en-US"/>
           </a:p>
         </p:txBody>
       </p:sp>
@@ -2763,7 +2549,7 @@
           <a:p>
             <a:fld id="{5BCAD085-E8A6-8845-BD4E-CB4CCA059FC4}" type="datetimeFigureOut">
               <a:rPr lang="en-US" smtClean="0"/>
-              <a:t>1/27/13</a:t>
+              <a:t>8/13/2026</a:t>
             </a:fld>
             <a:endParaRPr lang="en-US"/>
           </a:p>
@@ -2866,10 +2652,9 @@
           </a:lstStyle>
           <a:p>
             <a:r>
-              <a:rPr lang="en-US" smtClean="0"/>
+              <a:rPr lang="en-US"/>
               <a:t>Click to edit Master title style</a:t>
             </a:r>
-            <a:endParaRPr lang="en-US"/>
           </a:p>
         </p:txBody>
       </p:sp>
@@ -2986,7 +2771,7 @@
           <a:p>
             <a:pPr lvl="0"/>
             <a:r>
-              <a:rPr lang="en-US" smtClean="0"/>
+              <a:rPr lang="en-US"/>
               <a:t>Click to edit Master text styles</a:t>
             </a:r>
           </a:p>
@@ -3009,7 +2794,7 @@
           <a:p>
             <a:fld id="{5BCAD085-E8A6-8845-BD4E-CB4CCA059FC4}" type="datetimeFigureOut">
               <a:rPr lang="en-US" smtClean="0"/>
-              <a:t>1/27/13</a:t>
+              <a:t>8/13/2026</a:t>
             </a:fld>
             <a:endParaRPr lang="en-US"/>
           </a:p>
@@ -3103,10 +2888,9 @@
           <a:lstStyle/>
           <a:p>
             <a:r>
-              <a:rPr lang="en-US" smtClean="0"/>
+              <a:rPr lang="en-US"/>
               <a:t>Click to edit Master title style</a:t>
             </a:r>
-            <a:endParaRPr lang="en-US"/>
           </a:p>
         </p:txBody>
       </p:sp>
@@ -3160,38 +2944,37 @@
           <a:p>
             <a:pPr lvl="0"/>
             <a:r>
-              <a:rPr lang="en-US" smtClean="0"/>
+              <a:rPr lang="en-US"/>
               <a:t>Click to edit Master text styles</a:t>
             </a:r>
           </a:p>
           <a:p>
             <a:pPr lvl="1"/>
             <a:r>
-              <a:rPr lang="en-US" smtClean="0"/>
+              <a:rPr lang="en-US"/>
               <a:t>Second level</a:t>
             </a:r>
           </a:p>
           <a:p>
             <a:pPr lvl="2"/>
             <a:r>
-              <a:rPr lang="en-US" smtClean="0"/>
+              <a:rPr lang="en-US"/>
               <a:t>Third level</a:t>
             </a:r>
           </a:p>
           <a:p>
             <a:pPr lvl="3"/>
             <a:r>
-              <a:rPr lang="en-US" smtClean="0"/>
+              <a:rPr lang="en-US"/>
               <a:t>Fourth level</a:t>
             </a:r>
           </a:p>
           <a:p>
             <a:pPr lvl="4"/>
             <a:r>
-              <a:rPr lang="en-US" smtClean="0"/>
+              <a:rPr lang="en-US"/>
               <a:t>Fifth level</a:t>
             </a:r>
-            <a:endParaRPr lang="en-US"/>
           </a:p>
         </p:txBody>
       </p:sp>
@@ -3245,38 +3028,37 @@
           <a:p>
             <a:pPr lvl="0"/>
             <a:r>
-              <a:rPr lang="en-US" smtClean="0"/>
+              <a:rPr lang="en-US"/>
               <a:t>Click to edit Master text styles</a:t>
             </a:r>
           </a:p>
           <a:p>
             <a:pPr lvl="1"/>
             <a:r>
-              <a:rPr lang="en-US" smtClean="0"/>
+              <a:rPr lang="en-US"/>
               <a:t>Second level</a:t>
             </a:r>
           </a:p>
           <a:p>
             <a:pPr lvl="2"/>
             <a:r>
-              <a:rPr lang="en-US" smtClean="0"/>
+              <a:rPr lang="en-US"/>
               <a:t>Third level</a:t>
             </a:r>
           </a:p>
           <a:p>
             <a:pPr lvl="3"/>
             <a:r>
-              <a:rPr lang="en-US" smtClean="0"/>
+              <a:rPr lang="en-US"/>
               <a:t>Fourth level</a:t>
             </a:r>
           </a:p>
           <a:p>
             <a:pPr lvl="4"/>
             <a:r>
-              <a:rPr lang="en-US" smtClean="0"/>
+              <a:rPr lang="en-US"/>
               <a:t>Fifth level</a:t>
             </a:r>
-            <a:endParaRPr lang="en-US"/>
           </a:p>
         </p:txBody>
       </p:sp>
@@ -3297,7 +3079,7 @@
           <a:p>
             <a:fld id="{5BCAD085-E8A6-8845-BD4E-CB4CCA059FC4}" type="datetimeFigureOut">
               <a:rPr lang="en-US" smtClean="0"/>
-              <a:t>1/27/13</a:t>
+              <a:t>8/13/2026</a:t>
             </a:fld>
             <a:endParaRPr lang="en-US"/>
           </a:p>
@@ -3395,10 +3177,9 @@
           </a:lstStyle>
           <a:p>
             <a:r>
-              <a:rPr lang="en-US" smtClean="0"/>
+              <a:rPr lang="en-US"/>
               <a:t>Click to edit Master title style</a:t>
             </a:r>
-            <a:endParaRPr lang="en-US"/>
           </a:p>
         </p:txBody>
       </p:sp>
@@ -3461,7 +3242,7 @@
           <a:p>
             <a:pPr lvl="0"/>
             <a:r>
-              <a:rPr lang="en-US" smtClean="0"/>
+              <a:rPr lang="en-US"/>
               <a:t>Click to edit Master text styles</a:t>
             </a:r>
           </a:p>
@@ -3517,38 +3298,37 @@
           <a:p>
             <a:pPr lvl="0"/>
             <a:r>
-              <a:rPr lang="en-US" smtClean="0"/>
+              <a:rPr lang="en-US"/>
               <a:t>Click to edit Master text styles</a:t>
             </a:r>
           </a:p>
           <a:p>
             <a:pPr lvl="1"/>
             <a:r>
-              <a:rPr lang="en-US" smtClean="0"/>
+              <a:rPr lang="en-US"/>
               <a:t>Second level</a:t>
             </a:r>
           </a:p>
           <a:p>
             <a:pPr lvl="2"/>
             <a:r>
-              <a:rPr lang="en-US" smtClean="0"/>
+              <a:rPr lang="en-US"/>
               <a:t>Third level</a:t>
             </a:r>
           </a:p>
           <a:p>
             <a:pPr lvl="3"/>
             <a:r>
-              <a:rPr lang="en-US" smtClean="0"/>
+              <a:rPr lang="en-US"/>
               <a:t>Fourth level</a:t>
             </a:r>
           </a:p>
           <a:p>
             <a:pPr lvl="4"/>
             <a:r>
-              <a:rPr lang="en-US" smtClean="0"/>
+              <a:rPr lang="en-US"/>
               <a:t>Fifth level</a:t>
             </a:r>
-            <a:endParaRPr lang="en-US"/>
           </a:p>
         </p:txBody>
       </p:sp>
@@ -3611,7 +3391,7 @@
           <a:p>
             <a:pPr lvl="0"/>
             <a:r>
-              <a:rPr lang="en-US" smtClean="0"/>
+              <a:rPr lang="en-US"/>
               <a:t>Click to edit Master text styles</a:t>
             </a:r>
           </a:p>
@@ -3667,38 +3447,37 @@
           <a:p>
             <a:pPr lvl="0"/>
             <a:r>
-              <a:rPr lang="en-US" smtClean="0"/>
+              <a:rPr lang="en-US"/>
               <a:t>Click to edit Master text styles</a:t>
             </a:r>
           </a:p>
           <a:p>
             <a:pPr lvl="1"/>
             <a:r>
-              <a:rPr lang="en-US" smtClean="0"/>
+              <a:rPr lang="en-US"/>
               <a:t>Second level</a:t>
             </a:r>
           </a:p>
           <a:p>
             <a:pPr lvl="2"/>
             <a:r>
-              <a:rPr lang="en-US" smtClean="0"/>
+              <a:rPr lang="en-US"/>
               <a:t>Third level</a:t>
             </a:r>
           </a:p>
           <a:p>
             <a:pPr lvl="3"/>
             <a:r>
-              <a:rPr lang="en-US" smtClean="0"/>
+              <a:rPr lang="en-US"/>
               <a:t>Fourth level</a:t>
             </a:r>
           </a:p>
           <a:p>
             <a:pPr lvl="4"/>
             <a:r>
-              <a:rPr lang="en-US" smtClean="0"/>
+              <a:rPr lang="en-US"/>
               <a:t>Fifth level</a:t>
             </a:r>
-            <a:endParaRPr lang="en-US"/>
           </a:p>
         </p:txBody>
       </p:sp>
@@ -3719,7 +3498,7 @@
           <a:p>
             <a:fld id="{5BCAD085-E8A6-8845-BD4E-CB4CCA059FC4}" type="datetimeFigureOut">
               <a:rPr lang="en-US" smtClean="0"/>
-              <a:t>1/27/13</a:t>
+              <a:t>8/13/2026</a:t>
             </a:fld>
             <a:endParaRPr lang="en-US"/>
           </a:p>
@@ -3813,10 +3592,9 @@
           <a:lstStyle/>
           <a:p>
             <a:r>
-              <a:rPr lang="en-US" smtClean="0"/>
+              <a:rPr lang="en-US"/>
               <a:t>Click to edit Master title style</a:t>
             </a:r>
-            <a:endParaRPr lang="en-US"/>
           </a:p>
         </p:txBody>
       </p:sp>
@@ -3837,7 +3615,7 @@
           <a:p>
             <a:fld id="{5BCAD085-E8A6-8845-BD4E-CB4CCA059FC4}" type="datetimeFigureOut">
               <a:rPr lang="en-US" smtClean="0"/>
-              <a:t>1/27/13</a:t>
+              <a:t>8/13/2026</a:t>
             </a:fld>
             <a:endParaRPr lang="en-US"/>
           </a:p>
@@ -3932,7 +3710,7 @@
           <a:p>
             <a:fld id="{5BCAD085-E8A6-8845-BD4E-CB4CCA059FC4}" type="datetimeFigureOut">
               <a:rPr lang="en-US" smtClean="0"/>
-              <a:t>1/27/13</a:t>
+              <a:t>8/13/2026</a:t>
             </a:fld>
             <a:endParaRPr lang="en-US"/>
           </a:p>
@@ -4035,10 +3813,9 @@
           </a:lstStyle>
           <a:p>
             <a:r>
-              <a:rPr lang="en-US" smtClean="0"/>
+              <a:rPr lang="en-US"/>
               <a:t>Click to edit Master title style</a:t>
             </a:r>
-            <a:endParaRPr lang="en-US"/>
           </a:p>
         </p:txBody>
       </p:sp>
@@ -4092,38 +3869,37 @@
           <a:p>
             <a:pPr lvl="0"/>
             <a:r>
-              <a:rPr lang="en-US" smtClean="0"/>
+              <a:rPr lang="en-US"/>
               <a:t>Click to edit Master text styles</a:t>
             </a:r>
           </a:p>
           <a:p>
             <a:pPr lvl="1"/>
             <a:r>
-              <a:rPr lang="en-US" smtClean="0"/>
+              <a:rPr lang="en-US"/>
               <a:t>Second level</a:t>
             </a:r>
           </a:p>
           <a:p>
             <a:pPr lvl="2"/>
             <a:r>
-              <a:rPr lang="en-US" smtClean="0"/>
+              <a:rPr lang="en-US"/>
               <a:t>Third level</a:t>
             </a:r>
           </a:p>
           <a:p>
             <a:pPr lvl="3"/>
             <a:r>
-              <a:rPr lang="en-US" smtClean="0"/>
+              <a:rPr lang="en-US"/>
               <a:t>Fourth level</a:t>
             </a:r>
           </a:p>
           <a:p>
             <a:pPr lvl="4"/>
             <a:r>
-              <a:rPr lang="en-US" smtClean="0"/>
+              <a:rPr lang="en-US"/>
               <a:t>Fifth level</a:t>
             </a:r>
-            <a:endParaRPr lang="en-US"/>
           </a:p>
         </p:txBody>
       </p:sp>
@@ -4186,7 +3962,7 @@
           <a:p>
             <a:pPr lvl="0"/>
             <a:r>
-              <a:rPr lang="en-US" smtClean="0"/>
+              <a:rPr lang="en-US"/>
               <a:t>Click to edit Master text styles</a:t>
             </a:r>
           </a:p>
@@ -4209,7 +3985,7 @@
           <a:p>
             <a:fld id="{5BCAD085-E8A6-8845-BD4E-CB4CCA059FC4}" type="datetimeFigureOut">
               <a:rPr lang="en-US" smtClean="0"/>
-              <a:t>1/27/13</a:t>
+              <a:t>8/13/2026</a:t>
             </a:fld>
             <a:endParaRPr lang="en-US"/>
           </a:p>
@@ -4312,10 +4088,9 @@
           </a:lstStyle>
           <a:p>
             <a:r>
-              <a:rPr lang="en-US" smtClean="0"/>
+              <a:rPr lang="en-US"/>
               <a:t>Click to edit Master title style</a:t>
             </a:r>
-            <a:endParaRPr lang="en-US"/>
           </a:p>
         </p:txBody>
       </p:sp>
@@ -4439,7 +4214,7 @@
           <a:p>
             <a:pPr lvl="0"/>
             <a:r>
-              <a:rPr lang="en-US" smtClean="0"/>
+              <a:rPr lang="en-US"/>
               <a:t>Click to edit Master text styles</a:t>
             </a:r>
           </a:p>
@@ -4462,7 +4237,7 @@
           <a:p>
             <a:fld id="{5BCAD085-E8A6-8845-BD4E-CB4CCA059FC4}" type="datetimeFigureOut">
               <a:rPr lang="en-US" smtClean="0"/>
-              <a:t>1/27/13</a:t>
+              <a:t>8/13/2026</a:t>
             </a:fld>
             <a:endParaRPr lang="en-US"/>
           </a:p>
@@ -4571,10 +4346,9 @@
           <a:lstStyle/>
           <a:p>
             <a:r>
-              <a:rPr lang="en-US" smtClean="0"/>
+              <a:rPr lang="en-US"/>
               <a:t>Click to edit Master title style</a:t>
             </a:r>
-            <a:endParaRPr lang="en-US"/>
           </a:p>
         </p:txBody>
       </p:sp>
@@ -4605,38 +4379,37 @@
           <a:p>
             <a:pPr lvl="0"/>
             <a:r>
-              <a:rPr lang="en-US" smtClean="0"/>
+              <a:rPr lang="en-US"/>
               <a:t>Click to edit Master text styles</a:t>
             </a:r>
           </a:p>
           <a:p>
             <a:pPr lvl="1"/>
             <a:r>
-              <a:rPr lang="en-US" smtClean="0"/>
+              <a:rPr lang="en-US"/>
               <a:t>Second level</a:t>
             </a:r>
           </a:p>
           <a:p>
             <a:pPr lvl="2"/>
             <a:r>
-              <a:rPr lang="en-US" smtClean="0"/>
+              <a:rPr lang="en-US"/>
               <a:t>Third level</a:t>
             </a:r>
           </a:p>
           <a:p>
             <a:pPr lvl="3"/>
             <a:r>
-              <a:rPr lang="en-US" smtClean="0"/>
+              <a:rPr lang="en-US"/>
               <a:t>Fourth level</a:t>
             </a:r>
           </a:p>
           <a:p>
             <a:pPr lvl="4"/>
             <a:r>
-              <a:rPr lang="en-US" smtClean="0"/>
+              <a:rPr lang="en-US"/>
               <a:t>Fifth level</a:t>
             </a:r>
-            <a:endParaRPr lang="en-US"/>
           </a:p>
         </p:txBody>
       </p:sp>
@@ -4675,7 +4448,7 @@
           <a:p>
             <a:fld id="{5BCAD085-E8A6-8845-BD4E-CB4CCA059FC4}" type="datetimeFigureOut">
               <a:rPr lang="en-US" smtClean="0"/>
-              <a:t>1/27/13</a:t>
+              <a:t>8/13/2026</a:t>
             </a:fld>
             <a:endParaRPr lang="en-US"/>
           </a:p>
@@ -5034,7 +4807,7 @@
 </file>
 
 <file path=ppt/slides/slide1.xml><?xml version="1.0" encoding="utf-8"?>
-<p:sld xmlns:a="http://schemas.openxmlformats.org/drawingml/2006/main" xmlns:p="http://schemas.openxmlformats.org/presentationml/2006/main" xmlns:r="http://schemas.openxmlformats.org/officeDocument/2006/relationships">
+<p:sld xmlns:a="http://schemas.openxmlformats.org/drawingml/2006/main" xmlns:r="http://schemas.openxmlformats.org/officeDocument/2006/relationships" xmlns:p="http://schemas.openxmlformats.org/presentationml/2006/main">
   <p:cSld>
     <p:spTree>
       <p:nvGrpSpPr>
@@ -5042,7 +4815,14 @@
         <p:cNvGrpSpPr/>
         <p:nvPr/>
       </p:nvGrpSpPr>
-      <p:grpSpPr/>
+      <p:grpSpPr>
+        <a:xfrm>
+          <a:off x="0" y="0"/>
+          <a:ext cx="0" cy="0"/>
+          <a:chOff x="0" y="0"/>
+          <a:chExt cx="0" cy="0"/>
+        </a:xfrm>
+      </p:grpSpPr>
       <p:sp>
         <p:nvSpPr>
           <p:cNvPr id="2" name="Rectangle 1"/>
@@ -5083,6 +4863,7 @@
           <a:lstStyle/>
           <a:p>
             <a:pPr algn="ctr"/>
+            <a:endParaRPr/>
           </a:p>
         </p:txBody>
       </p:sp>
@@ -5109,7 +4890,7 @@
           <a:lstStyle/>
           <a:p>
             <a:pPr>
-              <a:defRPr b="1" sz="3000">
+              <a:defRPr sz="3000" b="1">
                 <a:solidFill>
                   <a:srgbClr val="FFFFFF"/>
                 </a:solidFill>
@@ -5200,6 +4981,7 @@
           <a:lstStyle/>
           <a:p>
             <a:pPr algn="ctr"/>
+            <a:endParaRPr/>
           </a:p>
         </p:txBody>
       </p:sp>
@@ -5243,6 +5025,7 @@
           <a:lstStyle/>
           <a:p>
             <a:pPr algn="ctr"/>
+            <a:endParaRPr/>
           </a:p>
         </p:txBody>
       </p:sp>
@@ -5269,7 +5052,7 @@
           <a:lstStyle/>
           <a:p>
             <a:pPr>
-              <a:defRPr b="1" sz="1500">
+              <a:defRPr sz="1500" b="1">
                 <a:solidFill>
                   <a:srgbClr val="1E2761"/>
                 </a:solidFill>
@@ -5340,6 +5123,7 @@
           <a:lstStyle/>
           <a:p>
             <a:pPr algn="ctr"/>
+            <a:endParaRPr/>
           </a:p>
         </p:txBody>
       </p:sp>
@@ -5383,6 +5167,7 @@
           <a:lstStyle/>
           <a:p>
             <a:pPr algn="ctr"/>
+            <a:endParaRPr/>
           </a:p>
         </p:txBody>
       </p:sp>
@@ -5409,7 +5194,7 @@
           <a:lstStyle/>
           <a:p>
             <a:pPr>
-              <a:defRPr b="1" sz="1500">
+              <a:defRPr sz="1500" b="1">
                 <a:solidFill>
                   <a:srgbClr val="1E2761"/>
                 </a:solidFill>
@@ -5480,6 +5265,7 @@
           <a:lstStyle/>
           <a:p>
             <a:pPr algn="ctr"/>
+            <a:endParaRPr/>
           </a:p>
         </p:txBody>
       </p:sp>
@@ -5523,6 +5309,7 @@
           <a:lstStyle/>
           <a:p>
             <a:pPr algn="ctr"/>
+            <a:endParaRPr/>
           </a:p>
         </p:txBody>
       </p:sp>
@@ -5549,7 +5336,7 @@
           <a:lstStyle/>
           <a:p>
             <a:pPr>
-              <a:defRPr b="1" sz="1500">
+              <a:defRPr sz="1500" b="1">
                 <a:solidFill>
                   <a:srgbClr val="1E2761"/>
                 </a:solidFill>
@@ -5587,7 +5374,7 @@
 </file>
 
 <file path=ppt/slides/slide10.xml><?xml version="1.0" encoding="utf-8"?>
-<p:sld xmlns:a="http://schemas.openxmlformats.org/drawingml/2006/main" xmlns:p="http://schemas.openxmlformats.org/presentationml/2006/main" xmlns:r="http://schemas.openxmlformats.org/officeDocument/2006/relationships">
+<p:sld xmlns:a="http://schemas.openxmlformats.org/drawingml/2006/main" xmlns:r="http://schemas.openxmlformats.org/officeDocument/2006/relationships" xmlns:p="http://schemas.openxmlformats.org/presentationml/2006/main">
   <p:cSld>
     <p:spTree>
       <p:nvGrpSpPr>
@@ -5595,7 +5382,14 @@
         <p:cNvGrpSpPr/>
         <p:nvPr/>
       </p:nvGrpSpPr>
-      <p:grpSpPr/>
+      <p:grpSpPr>
+        <a:xfrm>
+          <a:off x="0" y="0"/>
+          <a:ext cx="0" cy="0"/>
+          <a:chOff x="0" y="0"/>
+          <a:chExt cx="0" cy="0"/>
+        </a:xfrm>
+      </p:grpSpPr>
       <p:sp>
         <p:nvSpPr>
           <p:cNvPr id="2" name="Rectangle 1"/>
@@ -5636,6 +5430,7 @@
           <a:lstStyle/>
           <a:p>
             <a:pPr algn="ctr"/>
+            <a:endParaRPr/>
           </a:p>
         </p:txBody>
       </p:sp>
@@ -5662,7 +5457,7 @@
           <a:lstStyle/>
           <a:p>
             <a:pPr>
-              <a:defRPr b="1" sz="3000">
+              <a:defRPr sz="3000" b="1">
                 <a:solidFill>
                   <a:srgbClr val="1E2761"/>
                 </a:solidFill>
@@ -5717,6 +5512,7 @@
           <a:lstStyle/>
           <a:p>
             <a:pPr algn="ctr"/>
+            <a:endParaRPr/>
           </a:p>
         </p:txBody>
       </p:sp>
@@ -5760,6 +5556,7 @@
           <a:lstStyle/>
           <a:p>
             <a:pPr algn="ctr"/>
+            <a:endParaRPr/>
           </a:p>
         </p:txBody>
       </p:sp>
@@ -5786,7 +5583,7 @@
           <a:lstStyle/>
           <a:p>
             <a:pPr>
-              <a:defRPr b="1" sz="1500">
+              <a:defRPr sz="1500" b="1">
                 <a:solidFill>
                   <a:srgbClr val="1E2761"/>
                 </a:solidFill>
@@ -5853,6 +5650,7 @@
           <a:lstStyle/>
           <a:p>
             <a:pPr algn="ctr"/>
+            <a:endParaRPr/>
           </a:p>
         </p:txBody>
       </p:sp>
@@ -5896,6 +5694,7 @@
           <a:lstStyle/>
           <a:p>
             <a:pPr algn="ctr"/>
+            <a:endParaRPr/>
           </a:p>
         </p:txBody>
       </p:sp>
@@ -5922,7 +5721,7 @@
           <a:lstStyle/>
           <a:p>
             <a:pPr>
-              <a:defRPr b="1" sz="1500">
+              <a:defRPr sz="1500" b="1">
                 <a:solidFill>
                   <a:srgbClr val="1E2761"/>
                 </a:solidFill>
@@ -5997,6 +5796,7 @@
           <a:lstStyle/>
           <a:p>
             <a:pPr algn="ctr"/>
+            <a:endParaRPr/>
           </a:p>
         </p:txBody>
       </p:sp>
@@ -6040,6 +5840,7 @@
           <a:lstStyle/>
           <a:p>
             <a:pPr algn="ctr"/>
+            <a:endParaRPr/>
           </a:p>
         </p:txBody>
       </p:sp>
@@ -6066,7 +5867,7 @@
           <a:lstStyle/>
           <a:p>
             <a:pPr>
-              <a:defRPr b="1" sz="1500">
+              <a:defRPr sz="1500" b="1">
                 <a:solidFill>
                   <a:srgbClr val="1E2761"/>
                 </a:solidFill>
@@ -6123,7 +5924,7 @@
 </file>
 
 <file path=ppt/slides/slide11.xml><?xml version="1.0" encoding="utf-8"?>
-<p:sld xmlns:a="http://schemas.openxmlformats.org/drawingml/2006/main" xmlns:p="http://schemas.openxmlformats.org/presentationml/2006/main" xmlns:r="http://schemas.openxmlformats.org/officeDocument/2006/relationships">
+<p:sld xmlns:a="http://schemas.openxmlformats.org/drawingml/2006/main" xmlns:r="http://schemas.openxmlformats.org/officeDocument/2006/relationships" xmlns:p="http://schemas.openxmlformats.org/presentationml/2006/main">
   <p:cSld>
     <p:spTree>
       <p:nvGrpSpPr>
@@ -6131,7 +5932,14 @@
         <p:cNvGrpSpPr/>
         <p:nvPr/>
       </p:nvGrpSpPr>
-      <p:grpSpPr/>
+      <p:grpSpPr>
+        <a:xfrm>
+          <a:off x="0" y="0"/>
+          <a:ext cx="0" cy="0"/>
+          <a:chOff x="0" y="0"/>
+          <a:chExt cx="0" cy="0"/>
+        </a:xfrm>
+      </p:grpSpPr>
       <p:sp>
         <p:nvSpPr>
           <p:cNvPr id="2" name="Rectangle 1"/>
@@ -6172,6 +5980,7 @@
           <a:lstStyle/>
           <a:p>
             <a:pPr algn="ctr"/>
+            <a:endParaRPr/>
           </a:p>
         </p:txBody>
       </p:sp>
@@ -6198,7 +6007,7 @@
           <a:lstStyle/>
           <a:p>
             <a:pPr>
-              <a:defRPr b="1" sz="3000">
+              <a:defRPr sz="3000" b="1">
                 <a:solidFill>
                   <a:srgbClr val="1E2761"/>
                 </a:solidFill>
@@ -6253,6 +6062,7 @@
           <a:lstStyle/>
           <a:p>
             <a:pPr algn="ctr"/>
+            <a:endParaRPr/>
           </a:p>
         </p:txBody>
       </p:sp>
@@ -6296,6 +6106,7 @@
           <a:lstStyle/>
           <a:p>
             <a:pPr algn="ctr"/>
+            <a:endParaRPr/>
           </a:p>
         </p:txBody>
       </p:sp>
@@ -6322,7 +6133,7 @@
           <a:lstStyle/>
           <a:p>
             <a:pPr>
-              <a:defRPr b="1" sz="1500">
+              <a:defRPr sz="1500" b="1">
                 <a:solidFill>
                   <a:srgbClr val="1E2761"/>
                 </a:solidFill>
@@ -6385,6 +6196,7 @@
           <a:lstStyle/>
           <a:p>
             <a:pPr algn="ctr"/>
+            <a:endParaRPr/>
           </a:p>
         </p:txBody>
       </p:sp>
@@ -6428,6 +6240,7 @@
           <a:lstStyle/>
           <a:p>
             <a:pPr algn="ctr"/>
+            <a:endParaRPr/>
           </a:p>
         </p:txBody>
       </p:sp>
@@ -6454,7 +6267,7 @@
           <a:lstStyle/>
           <a:p>
             <a:pPr>
-              <a:defRPr b="1" sz="1500">
+              <a:defRPr sz="1500" b="1">
                 <a:solidFill>
                   <a:srgbClr val="1E2761"/>
                 </a:solidFill>
@@ -6529,6 +6342,7 @@
           <a:lstStyle/>
           <a:p>
             <a:pPr algn="ctr"/>
+            <a:endParaRPr/>
           </a:p>
         </p:txBody>
       </p:sp>
@@ -6572,6 +6386,7 @@
           <a:lstStyle/>
           <a:p>
             <a:pPr algn="ctr"/>
+            <a:endParaRPr/>
           </a:p>
         </p:txBody>
       </p:sp>
@@ -6598,7 +6413,7 @@
           <a:lstStyle/>
           <a:p>
             <a:pPr>
-              <a:defRPr b="1" sz="1500">
+              <a:defRPr sz="1500" b="1">
                 <a:solidFill>
                   <a:srgbClr val="1E2761"/>
                 </a:solidFill>
@@ -6655,7 +6470,7 @@
 </file>
 
 <file path=ppt/slides/slide12.xml><?xml version="1.0" encoding="utf-8"?>
-<p:sld xmlns:a="http://schemas.openxmlformats.org/drawingml/2006/main" xmlns:p="http://schemas.openxmlformats.org/presentationml/2006/main" xmlns:r="http://schemas.openxmlformats.org/officeDocument/2006/relationships">
+<p:sld xmlns:a="http://schemas.openxmlformats.org/drawingml/2006/main" xmlns:r="http://schemas.openxmlformats.org/officeDocument/2006/relationships" xmlns:p="http://schemas.openxmlformats.org/presentationml/2006/main">
   <p:cSld>
     <p:spTree>
       <p:nvGrpSpPr>
@@ -6663,7 +6478,14 @@
         <p:cNvGrpSpPr/>
         <p:nvPr/>
       </p:nvGrpSpPr>
-      <p:grpSpPr/>
+      <p:grpSpPr>
+        <a:xfrm>
+          <a:off x="0" y="0"/>
+          <a:ext cx="0" cy="0"/>
+          <a:chOff x="0" y="0"/>
+          <a:chExt cx="0" cy="0"/>
+        </a:xfrm>
+      </p:grpSpPr>
       <p:sp>
         <p:nvSpPr>
           <p:cNvPr id="2" name="Rectangle 1"/>
@@ -6704,6 +6526,7 @@
           <a:lstStyle/>
           <a:p>
             <a:pPr algn="ctr"/>
+            <a:endParaRPr/>
           </a:p>
         </p:txBody>
       </p:sp>
@@ -6730,7 +6553,7 @@
           <a:lstStyle/>
           <a:p>
             <a:pPr>
-              <a:defRPr b="1" sz="3000">
+              <a:defRPr sz="3000" b="1">
                 <a:solidFill>
                   <a:srgbClr val="1E2761"/>
                 </a:solidFill>
@@ -6785,6 +6608,7 @@
           <a:lstStyle/>
           <a:p>
             <a:pPr algn="ctr"/>
+            <a:endParaRPr/>
           </a:p>
         </p:txBody>
       </p:sp>
@@ -6828,6 +6652,7 @@
           <a:lstStyle/>
           <a:p>
             <a:pPr algn="ctr"/>
+            <a:endParaRPr/>
           </a:p>
         </p:txBody>
       </p:sp>
@@ -6854,7 +6679,7 @@
           <a:lstStyle/>
           <a:p>
             <a:pPr>
-              <a:defRPr b="1" sz="1500">
+              <a:defRPr sz="1500" b="1">
                 <a:solidFill>
                   <a:srgbClr val="1E2761"/>
                 </a:solidFill>
@@ -6917,6 +6742,7 @@
           <a:lstStyle/>
           <a:p>
             <a:pPr algn="ctr"/>
+            <a:endParaRPr/>
           </a:p>
         </p:txBody>
       </p:sp>
@@ -6960,6 +6786,7 @@
           <a:lstStyle/>
           <a:p>
             <a:pPr algn="ctr"/>
+            <a:endParaRPr/>
           </a:p>
         </p:txBody>
       </p:sp>
@@ -6986,7 +6813,7 @@
           <a:lstStyle/>
           <a:p>
             <a:pPr>
-              <a:defRPr b="1" sz="1500">
+              <a:defRPr sz="1500" b="1">
                 <a:solidFill>
                   <a:srgbClr val="1E2761"/>
                 </a:solidFill>
@@ -7061,6 +6888,7 @@
           <a:lstStyle/>
           <a:p>
             <a:pPr algn="ctr"/>
+            <a:endParaRPr/>
           </a:p>
         </p:txBody>
       </p:sp>
@@ -7104,6 +6932,7 @@
           <a:lstStyle/>
           <a:p>
             <a:pPr algn="ctr"/>
+            <a:endParaRPr/>
           </a:p>
         </p:txBody>
       </p:sp>
@@ -7130,7 +6959,7 @@
           <a:lstStyle/>
           <a:p>
             <a:pPr>
-              <a:defRPr b="1" sz="1500">
+              <a:defRPr sz="1500" b="1">
                 <a:solidFill>
                   <a:srgbClr val="1E2761"/>
                 </a:solidFill>
@@ -7187,7 +7016,7 @@
 </file>
 
 <file path=ppt/slides/slide13.xml><?xml version="1.0" encoding="utf-8"?>
-<p:sld xmlns:a="http://schemas.openxmlformats.org/drawingml/2006/main" xmlns:p="http://schemas.openxmlformats.org/presentationml/2006/main" xmlns:r="http://schemas.openxmlformats.org/officeDocument/2006/relationships">
+<p:sld xmlns:a="http://schemas.openxmlformats.org/drawingml/2006/main" xmlns:r="http://schemas.openxmlformats.org/officeDocument/2006/relationships" xmlns:p="http://schemas.openxmlformats.org/presentationml/2006/main">
   <p:cSld>
     <p:spTree>
       <p:nvGrpSpPr>
@@ -7195,7 +7024,14 @@
         <p:cNvGrpSpPr/>
         <p:nvPr/>
       </p:nvGrpSpPr>
-      <p:grpSpPr/>
+      <p:grpSpPr>
+        <a:xfrm>
+          <a:off x="0" y="0"/>
+          <a:ext cx="0" cy="0"/>
+          <a:chOff x="0" y="0"/>
+          <a:chExt cx="0" cy="0"/>
+        </a:xfrm>
+      </p:grpSpPr>
       <p:sp>
         <p:nvSpPr>
           <p:cNvPr id="2" name="Rectangle 1"/>
@@ -7236,6 +7072,7 @@
           <a:lstStyle/>
           <a:p>
             <a:pPr algn="ctr"/>
+            <a:endParaRPr/>
           </a:p>
         </p:txBody>
       </p:sp>
@@ -7262,7 +7099,7 @@
           <a:lstStyle/>
           <a:p>
             <a:pPr>
-              <a:defRPr b="1" sz="3000">
+              <a:defRPr sz="3000" b="1">
                 <a:solidFill>
                   <a:srgbClr val="1E2761"/>
                 </a:solidFill>
@@ -7317,6 +7154,7 @@
           <a:lstStyle/>
           <a:p>
             <a:pPr algn="ctr"/>
+            <a:endParaRPr/>
           </a:p>
         </p:txBody>
       </p:sp>
@@ -7360,6 +7198,7 @@
           <a:lstStyle/>
           <a:p>
             <a:pPr algn="ctr"/>
+            <a:endParaRPr/>
           </a:p>
         </p:txBody>
       </p:sp>
@@ -7386,7 +7225,7 @@
           <a:lstStyle/>
           <a:p>
             <a:pPr>
-              <a:defRPr b="1" sz="1500">
+              <a:defRPr sz="1500" b="1">
                 <a:solidFill>
                   <a:srgbClr val="1E2761"/>
                 </a:solidFill>
@@ -7453,6 +7292,7 @@
           <a:lstStyle/>
           <a:p>
             <a:pPr algn="ctr"/>
+            <a:endParaRPr/>
           </a:p>
         </p:txBody>
       </p:sp>
@@ -7496,6 +7336,7 @@
           <a:lstStyle/>
           <a:p>
             <a:pPr algn="ctr"/>
+            <a:endParaRPr/>
           </a:p>
         </p:txBody>
       </p:sp>
@@ -7522,7 +7363,7 @@
           <a:lstStyle/>
           <a:p>
             <a:pPr>
-              <a:defRPr b="1" sz="1500">
+              <a:defRPr sz="1500" b="1">
                 <a:solidFill>
                   <a:srgbClr val="1E2761"/>
                 </a:solidFill>
@@ -7597,6 +7438,7 @@
           <a:lstStyle/>
           <a:p>
             <a:pPr algn="ctr"/>
+            <a:endParaRPr/>
           </a:p>
         </p:txBody>
       </p:sp>
@@ -7640,6 +7482,7 @@
           <a:lstStyle/>
           <a:p>
             <a:pPr algn="ctr"/>
+            <a:endParaRPr/>
           </a:p>
         </p:txBody>
       </p:sp>
@@ -7666,7 +7509,7 @@
           <a:lstStyle/>
           <a:p>
             <a:pPr>
-              <a:defRPr b="1" sz="1500">
+              <a:defRPr sz="1500" b="1">
                 <a:solidFill>
                   <a:srgbClr val="1E2761"/>
                 </a:solidFill>
@@ -7723,7 +7566,7 @@
 </file>
 
 <file path=ppt/slides/slide14.xml><?xml version="1.0" encoding="utf-8"?>
-<p:sld xmlns:a="http://schemas.openxmlformats.org/drawingml/2006/main" xmlns:p="http://schemas.openxmlformats.org/presentationml/2006/main" xmlns:r="http://schemas.openxmlformats.org/officeDocument/2006/relationships">
+<p:sld xmlns:a="http://schemas.openxmlformats.org/drawingml/2006/main" xmlns:r="http://schemas.openxmlformats.org/officeDocument/2006/relationships" xmlns:p="http://schemas.openxmlformats.org/presentationml/2006/main">
   <p:cSld>
     <p:spTree>
       <p:nvGrpSpPr>
@@ -7731,7 +7574,14 @@
         <p:cNvGrpSpPr/>
         <p:nvPr/>
       </p:nvGrpSpPr>
-      <p:grpSpPr/>
+      <p:grpSpPr>
+        <a:xfrm>
+          <a:off x="0" y="0"/>
+          <a:ext cx="0" cy="0"/>
+          <a:chOff x="0" y="0"/>
+          <a:chExt cx="0" cy="0"/>
+        </a:xfrm>
+      </p:grpSpPr>
       <p:sp>
         <p:nvSpPr>
           <p:cNvPr id="2" name="Rectangle 1"/>
@@ -7772,6 +7622,7 @@
           <a:lstStyle/>
           <a:p>
             <a:pPr algn="ctr"/>
+            <a:endParaRPr/>
           </a:p>
         </p:txBody>
       </p:sp>
@@ -7798,7 +7649,7 @@
           <a:lstStyle/>
           <a:p>
             <a:pPr>
-              <a:defRPr b="1" sz="3000">
+              <a:defRPr sz="3000" b="1">
                 <a:solidFill>
                   <a:srgbClr val="1E2761"/>
                 </a:solidFill>
@@ -7853,6 +7704,7 @@
           <a:lstStyle/>
           <a:p>
             <a:pPr algn="ctr"/>
+            <a:endParaRPr/>
           </a:p>
         </p:txBody>
       </p:sp>
@@ -7896,6 +7748,7 @@
           <a:lstStyle/>
           <a:p>
             <a:pPr algn="ctr"/>
+            <a:endParaRPr/>
           </a:p>
         </p:txBody>
       </p:sp>
@@ -7922,7 +7775,7 @@
           <a:lstStyle/>
           <a:p>
             <a:pPr>
-              <a:defRPr b="1" sz="1500">
+              <a:defRPr sz="1500" b="1">
                 <a:solidFill>
                   <a:srgbClr val="1E2761"/>
                 </a:solidFill>
@@ -7985,6 +7838,7 @@
           <a:lstStyle/>
           <a:p>
             <a:pPr algn="ctr"/>
+            <a:endParaRPr/>
           </a:p>
         </p:txBody>
       </p:sp>
@@ -8028,6 +7882,7 @@
           <a:lstStyle/>
           <a:p>
             <a:pPr algn="ctr"/>
+            <a:endParaRPr/>
           </a:p>
         </p:txBody>
       </p:sp>
@@ -8054,7 +7909,7 @@
           <a:lstStyle/>
           <a:p>
             <a:pPr>
-              <a:defRPr b="1" sz="1500">
+              <a:defRPr sz="1500" b="1">
                 <a:solidFill>
                   <a:srgbClr val="1E2761"/>
                 </a:solidFill>
@@ -8125,6 +7980,7 @@
           <a:lstStyle/>
           <a:p>
             <a:pPr algn="ctr"/>
+            <a:endParaRPr/>
           </a:p>
         </p:txBody>
       </p:sp>
@@ -8168,6 +8024,7 @@
           <a:lstStyle/>
           <a:p>
             <a:pPr algn="ctr"/>
+            <a:endParaRPr/>
           </a:p>
         </p:txBody>
       </p:sp>
@@ -8194,7 +8051,7 @@
           <a:lstStyle/>
           <a:p>
             <a:pPr>
-              <a:defRPr b="1" sz="1500">
+              <a:defRPr sz="1500" b="1">
                 <a:solidFill>
                   <a:srgbClr val="1E2761"/>
                 </a:solidFill>
@@ -8251,7 +8108,7 @@
 </file>
 
 <file path=ppt/slides/slide15.xml><?xml version="1.0" encoding="utf-8"?>
-<p:sld xmlns:a="http://schemas.openxmlformats.org/drawingml/2006/main" xmlns:p="http://schemas.openxmlformats.org/presentationml/2006/main" xmlns:r="http://schemas.openxmlformats.org/officeDocument/2006/relationships">
+<p:sld xmlns:a="http://schemas.openxmlformats.org/drawingml/2006/main" xmlns:r="http://schemas.openxmlformats.org/officeDocument/2006/relationships" xmlns:p="http://schemas.openxmlformats.org/presentationml/2006/main">
   <p:cSld>
     <p:spTree>
       <p:nvGrpSpPr>
@@ -8259,7 +8116,14 @@
         <p:cNvGrpSpPr/>
         <p:nvPr/>
       </p:nvGrpSpPr>
-      <p:grpSpPr/>
+      <p:grpSpPr>
+        <a:xfrm>
+          <a:off x="0" y="0"/>
+          <a:ext cx="0" cy="0"/>
+          <a:chOff x="0" y="0"/>
+          <a:chExt cx="0" cy="0"/>
+        </a:xfrm>
+      </p:grpSpPr>
       <p:sp>
         <p:nvSpPr>
           <p:cNvPr id="2" name="Rectangle 1"/>
@@ -8300,6 +8164,7 @@
           <a:lstStyle/>
           <a:p>
             <a:pPr algn="ctr"/>
+            <a:endParaRPr/>
           </a:p>
         </p:txBody>
       </p:sp>
@@ -8326,7 +8191,7 @@
           <a:lstStyle/>
           <a:p>
             <a:pPr>
-              <a:defRPr b="1" sz="3000">
+              <a:defRPr sz="3000" b="1">
                 <a:solidFill>
                   <a:srgbClr val="1E2761"/>
                 </a:solidFill>
@@ -8381,6 +8246,7 @@
           <a:lstStyle/>
           <a:p>
             <a:pPr algn="ctr"/>
+            <a:endParaRPr/>
           </a:p>
         </p:txBody>
       </p:sp>
@@ -8424,6 +8290,7 @@
           <a:lstStyle/>
           <a:p>
             <a:pPr algn="ctr"/>
+            <a:endParaRPr/>
           </a:p>
         </p:txBody>
       </p:sp>
@@ -8450,7 +8317,7 @@
           <a:lstStyle/>
           <a:p>
             <a:pPr>
-              <a:defRPr b="1" sz="1500">
+              <a:defRPr sz="1500" b="1">
                 <a:solidFill>
                   <a:srgbClr val="1E2761"/>
                 </a:solidFill>
@@ -8513,6 +8380,7 @@
           <a:lstStyle/>
           <a:p>
             <a:pPr algn="ctr"/>
+            <a:endParaRPr/>
           </a:p>
         </p:txBody>
       </p:sp>
@@ -8556,6 +8424,7 @@
           <a:lstStyle/>
           <a:p>
             <a:pPr algn="ctr"/>
+            <a:endParaRPr/>
           </a:p>
         </p:txBody>
       </p:sp>
@@ -8582,7 +8451,7 @@
           <a:lstStyle/>
           <a:p>
             <a:pPr>
-              <a:defRPr b="1" sz="1500">
+              <a:defRPr sz="1500" b="1">
                 <a:solidFill>
                   <a:srgbClr val="1E2761"/>
                 </a:solidFill>
@@ -8653,6 +8522,7 @@
           <a:lstStyle/>
           <a:p>
             <a:pPr algn="ctr"/>
+            <a:endParaRPr/>
           </a:p>
         </p:txBody>
       </p:sp>
@@ -8696,6 +8566,7 @@
           <a:lstStyle/>
           <a:p>
             <a:pPr algn="ctr"/>
+            <a:endParaRPr/>
           </a:p>
         </p:txBody>
       </p:sp>
@@ -8722,7 +8593,7 @@
           <a:lstStyle/>
           <a:p>
             <a:pPr>
-              <a:defRPr b="1" sz="1500">
+              <a:defRPr sz="1500" b="1">
                 <a:solidFill>
                   <a:srgbClr val="1E2761"/>
                 </a:solidFill>
@@ -8779,7 +8650,7 @@
 </file>
 
 <file path=ppt/slides/slide16.xml><?xml version="1.0" encoding="utf-8"?>
-<p:sld xmlns:a="http://schemas.openxmlformats.org/drawingml/2006/main" xmlns:p="http://schemas.openxmlformats.org/presentationml/2006/main" xmlns:r="http://schemas.openxmlformats.org/officeDocument/2006/relationships">
+<p:sld xmlns:a="http://schemas.openxmlformats.org/drawingml/2006/main" xmlns:r="http://schemas.openxmlformats.org/officeDocument/2006/relationships" xmlns:p="http://schemas.openxmlformats.org/presentationml/2006/main">
   <p:cSld>
     <p:spTree>
       <p:nvGrpSpPr>
@@ -8787,7 +8658,14 @@
         <p:cNvGrpSpPr/>
         <p:nvPr/>
       </p:nvGrpSpPr>
-      <p:grpSpPr/>
+      <p:grpSpPr>
+        <a:xfrm>
+          <a:off x="0" y="0"/>
+          <a:ext cx="0" cy="0"/>
+          <a:chOff x="0" y="0"/>
+          <a:chExt cx="0" cy="0"/>
+        </a:xfrm>
+      </p:grpSpPr>
       <p:sp>
         <p:nvSpPr>
           <p:cNvPr id="2" name="Rectangle 1"/>
@@ -8828,6 +8706,7 @@
           <a:lstStyle/>
           <a:p>
             <a:pPr algn="ctr"/>
+            <a:endParaRPr/>
           </a:p>
         </p:txBody>
       </p:sp>
@@ -8854,7 +8733,7 @@
           <a:lstStyle/>
           <a:p>
             <a:pPr>
-              <a:defRPr b="1" sz="3000">
+              <a:defRPr sz="3000" b="1">
                 <a:solidFill>
                   <a:srgbClr val="1E2761"/>
                 </a:solidFill>
@@ -8945,6 +8824,7 @@
           <a:lstStyle/>
           <a:p>
             <a:pPr algn="ctr"/>
+            <a:endParaRPr/>
           </a:p>
         </p:txBody>
       </p:sp>
@@ -8988,6 +8868,7 @@
           <a:lstStyle/>
           <a:p>
             <a:pPr algn="ctr"/>
+            <a:endParaRPr/>
           </a:p>
         </p:txBody>
       </p:sp>
@@ -9014,7 +8895,7 @@
           <a:lstStyle/>
           <a:p>
             <a:pPr>
-              <a:defRPr b="1" sz="1500">
+              <a:defRPr sz="1500" b="1">
                 <a:solidFill>
                   <a:srgbClr val="1E2761"/>
                 </a:solidFill>
@@ -9085,6 +8966,7 @@
           <a:lstStyle/>
           <a:p>
             <a:pPr algn="ctr"/>
+            <a:endParaRPr/>
           </a:p>
         </p:txBody>
       </p:sp>
@@ -9128,6 +9010,7 @@
           <a:lstStyle/>
           <a:p>
             <a:pPr algn="ctr"/>
+            <a:endParaRPr/>
           </a:p>
         </p:txBody>
       </p:sp>
@@ -9154,7 +9037,7 @@
           <a:lstStyle/>
           <a:p>
             <a:pPr>
-              <a:defRPr b="1" sz="1500">
+              <a:defRPr sz="1500" b="1">
                 <a:solidFill>
                   <a:srgbClr val="1E2761"/>
                 </a:solidFill>
@@ -9225,6 +9108,7 @@
           <a:lstStyle/>
           <a:p>
             <a:pPr algn="ctr"/>
+            <a:endParaRPr/>
           </a:p>
         </p:txBody>
       </p:sp>
@@ -9268,6 +9152,7 @@
           <a:lstStyle/>
           <a:p>
             <a:pPr algn="ctr"/>
+            <a:endParaRPr/>
           </a:p>
         </p:txBody>
       </p:sp>
@@ -9294,7 +9179,7 @@
           <a:lstStyle/>
           <a:p>
             <a:pPr>
-              <a:defRPr b="1" sz="1500">
+              <a:defRPr sz="1500" b="1">
                 <a:solidFill>
                   <a:srgbClr val="1E2761"/>
                 </a:solidFill>
@@ -9365,6 +9250,7 @@
           <a:lstStyle/>
           <a:p>
             <a:pPr algn="ctr"/>
+            <a:endParaRPr/>
           </a:p>
         </p:txBody>
       </p:sp>
@@ -9408,6 +9294,7 @@
           <a:lstStyle/>
           <a:p>
             <a:pPr algn="ctr"/>
+            <a:endParaRPr/>
           </a:p>
         </p:txBody>
       </p:sp>
@@ -9434,7 +9321,7 @@
           <a:lstStyle/>
           <a:p>
             <a:pPr>
-              <a:defRPr b="1" sz="1500">
+              <a:defRPr sz="1500" b="1">
                 <a:solidFill>
                   <a:srgbClr val="1E2761"/>
                 </a:solidFill>
@@ -9505,6 +9392,7 @@
           <a:lstStyle/>
           <a:p>
             <a:pPr algn="ctr"/>
+            <a:endParaRPr/>
           </a:p>
         </p:txBody>
       </p:sp>
@@ -9548,6 +9436,7 @@
           <a:lstStyle/>
           <a:p>
             <a:pPr algn="ctr"/>
+            <a:endParaRPr/>
           </a:p>
         </p:txBody>
       </p:sp>
@@ -9574,7 +9463,7 @@
           <a:lstStyle/>
           <a:p>
             <a:pPr>
-              <a:defRPr b="1" sz="1500">
+              <a:defRPr sz="1500" b="1">
                 <a:solidFill>
                   <a:srgbClr val="1E2761"/>
                 </a:solidFill>
@@ -9647,7 +9536,7 @@
 </file>
 
 <file path=ppt/slides/slide2.xml><?xml version="1.0" encoding="utf-8"?>
-<p:sld xmlns:a="http://schemas.openxmlformats.org/drawingml/2006/main" xmlns:p="http://schemas.openxmlformats.org/presentationml/2006/main" xmlns:r="http://schemas.openxmlformats.org/officeDocument/2006/relationships">
+<p:sld xmlns:a="http://schemas.openxmlformats.org/drawingml/2006/main" xmlns:r="http://schemas.openxmlformats.org/officeDocument/2006/relationships" xmlns:p="http://schemas.openxmlformats.org/presentationml/2006/main">
   <p:cSld>
     <p:spTree>
       <p:nvGrpSpPr>
@@ -9655,7 +9544,14 @@
         <p:cNvGrpSpPr/>
         <p:nvPr/>
       </p:nvGrpSpPr>
-      <p:grpSpPr/>
+      <p:grpSpPr>
+        <a:xfrm>
+          <a:off x="0" y="0"/>
+          <a:ext cx="0" cy="0"/>
+          <a:chOff x="0" y="0"/>
+          <a:chExt cx="0" cy="0"/>
+        </a:xfrm>
+      </p:grpSpPr>
       <p:sp>
         <p:nvSpPr>
           <p:cNvPr id="2" name="Rectangle 1"/>
@@ -9696,6 +9592,7 @@
           <a:lstStyle/>
           <a:p>
             <a:pPr algn="ctr"/>
+            <a:endParaRPr/>
           </a:p>
         </p:txBody>
       </p:sp>
@@ -9722,7 +9619,7 @@
           <a:lstStyle/>
           <a:p>
             <a:pPr>
-              <a:defRPr b="1" sz="3000">
+              <a:defRPr sz="3000" b="1">
                 <a:solidFill>
                   <a:srgbClr val="1E2761"/>
                 </a:solidFill>
@@ -9777,6 +9674,7 @@
           <a:lstStyle/>
           <a:p>
             <a:pPr algn="ctr"/>
+            <a:endParaRPr/>
           </a:p>
         </p:txBody>
       </p:sp>
@@ -9820,6 +9718,7 @@
           <a:lstStyle/>
           <a:p>
             <a:pPr algn="ctr"/>
+            <a:endParaRPr/>
           </a:p>
         </p:txBody>
       </p:sp>
@@ -9846,7 +9745,7 @@
           <a:lstStyle/>
           <a:p>
             <a:pPr>
-              <a:defRPr b="1" sz="1500">
+              <a:defRPr sz="1500" b="1">
                 <a:solidFill>
                   <a:srgbClr val="1E2761"/>
                 </a:solidFill>
@@ -9917,6 +9816,7 @@
           <a:lstStyle/>
           <a:p>
             <a:pPr algn="ctr"/>
+            <a:endParaRPr/>
           </a:p>
         </p:txBody>
       </p:sp>
@@ -9960,6 +9860,7 @@
           <a:lstStyle/>
           <a:p>
             <a:pPr algn="ctr"/>
+            <a:endParaRPr/>
           </a:p>
         </p:txBody>
       </p:sp>
@@ -9986,7 +9887,7 @@
           <a:lstStyle/>
           <a:p>
             <a:pPr>
-              <a:defRPr b="1" sz="1500">
+              <a:defRPr sz="1500" b="1">
                 <a:solidFill>
                   <a:srgbClr val="1E2761"/>
                 </a:solidFill>
@@ -10057,6 +9958,7 @@
           <a:lstStyle/>
           <a:p>
             <a:pPr algn="ctr"/>
+            <a:endParaRPr/>
           </a:p>
         </p:txBody>
       </p:sp>
@@ -10100,6 +10002,7 @@
           <a:lstStyle/>
           <a:p>
             <a:pPr algn="ctr"/>
+            <a:endParaRPr/>
           </a:p>
         </p:txBody>
       </p:sp>
@@ -10126,7 +10029,7 @@
           <a:lstStyle/>
           <a:p>
             <a:pPr>
-              <a:defRPr b="1" sz="1500">
+              <a:defRPr sz="1500" b="1">
                 <a:solidFill>
                   <a:srgbClr val="1E2761"/>
                 </a:solidFill>
@@ -10197,6 +10100,7 @@
           <a:lstStyle/>
           <a:p>
             <a:pPr algn="ctr"/>
+            <a:endParaRPr/>
           </a:p>
         </p:txBody>
       </p:sp>
@@ -10240,6 +10144,7 @@
           <a:lstStyle/>
           <a:p>
             <a:pPr algn="ctr"/>
+            <a:endParaRPr/>
           </a:p>
         </p:txBody>
       </p:sp>
@@ -10266,7 +10171,7 @@
           <a:lstStyle/>
           <a:p>
             <a:pPr>
-              <a:defRPr b="1" sz="1500">
+              <a:defRPr sz="1500" b="1">
                 <a:solidFill>
                   <a:srgbClr val="1E2761"/>
                 </a:solidFill>
@@ -10337,6 +10242,7 @@
           <a:lstStyle/>
           <a:p>
             <a:pPr algn="ctr"/>
+            <a:endParaRPr/>
           </a:p>
         </p:txBody>
       </p:sp>
@@ -10380,6 +10286,7 @@
           <a:lstStyle/>
           <a:p>
             <a:pPr algn="ctr"/>
+            <a:endParaRPr/>
           </a:p>
         </p:txBody>
       </p:sp>
@@ -10406,7 +10313,7 @@
           <a:lstStyle/>
           <a:p>
             <a:pPr>
-              <a:defRPr b="1" sz="1500">
+              <a:defRPr sz="1500" b="1">
                 <a:solidFill>
                   <a:srgbClr val="1E2761"/>
                 </a:solidFill>
@@ -10477,6 +10384,7 @@
           <a:lstStyle/>
           <a:p>
             <a:pPr algn="ctr"/>
+            <a:endParaRPr/>
           </a:p>
         </p:txBody>
       </p:sp>
@@ -10520,6 +10428,7 @@
           <a:lstStyle/>
           <a:p>
             <a:pPr algn="ctr"/>
+            <a:endParaRPr/>
           </a:p>
         </p:txBody>
       </p:sp>
@@ -10546,7 +10455,7 @@
           <a:lstStyle/>
           <a:p>
             <a:pPr>
-              <a:defRPr b="1" sz="1500">
+              <a:defRPr sz="1500" b="1">
                 <a:solidFill>
                   <a:srgbClr val="1E2761"/>
                 </a:solidFill>
@@ -10617,6 +10526,7 @@
           <a:lstStyle/>
           <a:p>
             <a:pPr algn="ctr"/>
+            <a:endParaRPr/>
           </a:p>
         </p:txBody>
       </p:sp>
@@ -10660,6 +10570,7 @@
           <a:lstStyle/>
           <a:p>
             <a:pPr algn="ctr"/>
+            <a:endParaRPr/>
           </a:p>
         </p:txBody>
       </p:sp>
@@ -10686,7 +10597,7 @@
           <a:lstStyle/>
           <a:p>
             <a:pPr>
-              <a:defRPr b="1" sz="1500">
+              <a:defRPr sz="1500" b="1">
                 <a:solidFill>
                   <a:srgbClr val="1E2761"/>
                 </a:solidFill>
@@ -10757,6 +10668,7 @@
           <a:lstStyle/>
           <a:p>
             <a:pPr algn="ctr"/>
+            <a:endParaRPr/>
           </a:p>
         </p:txBody>
       </p:sp>
@@ -10800,6 +10712,7 @@
           <a:lstStyle/>
           <a:p>
             <a:pPr algn="ctr"/>
+            <a:endParaRPr/>
           </a:p>
         </p:txBody>
       </p:sp>
@@ -10826,7 +10739,7 @@
           <a:lstStyle/>
           <a:p>
             <a:pPr>
-              <a:defRPr b="1" sz="1500">
+              <a:defRPr sz="1500" b="1">
                 <a:solidFill>
                   <a:srgbClr val="1E2761"/>
                 </a:solidFill>
@@ -10899,7 +10812,7 @@
 </file>
 
 <file path=ppt/slides/slide3.xml><?xml version="1.0" encoding="utf-8"?>
-<p:sld xmlns:a="http://schemas.openxmlformats.org/drawingml/2006/main" xmlns:p="http://schemas.openxmlformats.org/presentationml/2006/main" xmlns:r="http://schemas.openxmlformats.org/officeDocument/2006/relationships">
+<p:sld xmlns:a="http://schemas.openxmlformats.org/drawingml/2006/main" xmlns:r="http://schemas.openxmlformats.org/officeDocument/2006/relationships" xmlns:p="http://schemas.openxmlformats.org/presentationml/2006/main">
   <p:cSld>
     <p:spTree>
       <p:nvGrpSpPr>
@@ -10907,7 +10820,14 @@
         <p:cNvGrpSpPr/>
         <p:nvPr/>
       </p:nvGrpSpPr>
-      <p:grpSpPr/>
+      <p:grpSpPr>
+        <a:xfrm>
+          <a:off x="0" y="0"/>
+          <a:ext cx="0" cy="0"/>
+          <a:chOff x="0" y="0"/>
+          <a:chExt cx="0" cy="0"/>
+        </a:xfrm>
+      </p:grpSpPr>
       <p:sp>
         <p:nvSpPr>
           <p:cNvPr id="2" name="Rectangle 1"/>
@@ -10948,6 +10868,7 @@
           <a:lstStyle/>
           <a:p>
             <a:pPr algn="ctr"/>
+            <a:endParaRPr/>
           </a:p>
         </p:txBody>
       </p:sp>
@@ -10974,7 +10895,7 @@
           <a:lstStyle/>
           <a:p>
             <a:pPr>
-              <a:defRPr b="1" sz="3000">
+              <a:defRPr sz="3000" b="1">
                 <a:solidFill>
                   <a:srgbClr val="1E2761"/>
                 </a:solidFill>
@@ -11029,6 +10950,7 @@
           <a:lstStyle/>
           <a:p>
             <a:pPr algn="ctr"/>
+            <a:endParaRPr/>
           </a:p>
         </p:txBody>
       </p:sp>
@@ -11072,6 +10994,7 @@
           <a:lstStyle/>
           <a:p>
             <a:pPr algn="ctr"/>
+            <a:endParaRPr/>
           </a:p>
         </p:txBody>
       </p:sp>
@@ -11098,7 +11021,7 @@
           <a:lstStyle/>
           <a:p>
             <a:pPr>
-              <a:defRPr b="1" sz="1500">
+              <a:defRPr sz="1500" b="1">
                 <a:solidFill>
                   <a:srgbClr val="1E2761"/>
                 </a:solidFill>
@@ -11161,6 +11084,7 @@
           <a:lstStyle/>
           <a:p>
             <a:pPr algn="ctr"/>
+            <a:endParaRPr/>
           </a:p>
         </p:txBody>
       </p:sp>
@@ -11204,6 +11128,7 @@
           <a:lstStyle/>
           <a:p>
             <a:pPr algn="ctr"/>
+            <a:endParaRPr/>
           </a:p>
         </p:txBody>
       </p:sp>
@@ -11230,7 +11155,7 @@
           <a:lstStyle/>
           <a:p>
             <a:pPr>
-              <a:defRPr b="1" sz="1500">
+              <a:defRPr sz="1500" b="1">
                 <a:solidFill>
                   <a:srgbClr val="1E2761"/>
                 </a:solidFill>
@@ -11301,6 +11226,7 @@
           <a:lstStyle/>
           <a:p>
             <a:pPr algn="ctr"/>
+            <a:endParaRPr/>
           </a:p>
         </p:txBody>
       </p:sp>
@@ -11344,6 +11270,7 @@
           <a:lstStyle/>
           <a:p>
             <a:pPr algn="ctr"/>
+            <a:endParaRPr/>
           </a:p>
         </p:txBody>
       </p:sp>
@@ -11370,7 +11297,7 @@
           <a:lstStyle/>
           <a:p>
             <a:pPr>
-              <a:defRPr b="1" sz="1500">
+              <a:defRPr sz="1500" b="1">
                 <a:solidFill>
                   <a:srgbClr val="1E2761"/>
                 </a:solidFill>
@@ -11427,7 +11354,7 @@
 </file>
 
 <file path=ppt/slides/slide4.xml><?xml version="1.0" encoding="utf-8"?>
-<p:sld xmlns:a="http://schemas.openxmlformats.org/drawingml/2006/main" xmlns:p="http://schemas.openxmlformats.org/presentationml/2006/main" xmlns:r="http://schemas.openxmlformats.org/officeDocument/2006/relationships">
+<p:sld xmlns:a="http://schemas.openxmlformats.org/drawingml/2006/main" xmlns:r="http://schemas.openxmlformats.org/officeDocument/2006/relationships" xmlns:p="http://schemas.openxmlformats.org/presentationml/2006/main">
   <p:cSld>
     <p:spTree>
       <p:nvGrpSpPr>
@@ -11435,7 +11362,14 @@
         <p:cNvGrpSpPr/>
         <p:nvPr/>
       </p:nvGrpSpPr>
-      <p:grpSpPr/>
+      <p:grpSpPr>
+        <a:xfrm>
+          <a:off x="0" y="0"/>
+          <a:ext cx="0" cy="0"/>
+          <a:chOff x="0" y="0"/>
+          <a:chExt cx="0" cy="0"/>
+        </a:xfrm>
+      </p:grpSpPr>
       <p:sp>
         <p:nvSpPr>
           <p:cNvPr id="2" name="Rectangle 1"/>
@@ -11476,6 +11410,7 @@
           <a:lstStyle/>
           <a:p>
             <a:pPr algn="ctr"/>
+            <a:endParaRPr/>
           </a:p>
         </p:txBody>
       </p:sp>
@@ -11502,7 +11437,7 @@
           <a:lstStyle/>
           <a:p>
             <a:pPr>
-              <a:defRPr b="1" sz="3000">
+              <a:defRPr sz="3000" b="1">
                 <a:solidFill>
                   <a:srgbClr val="1E2761"/>
                 </a:solidFill>
@@ -11557,6 +11492,7 @@
           <a:lstStyle/>
           <a:p>
             <a:pPr algn="ctr"/>
+            <a:endParaRPr/>
           </a:p>
         </p:txBody>
       </p:sp>
@@ -11600,6 +11536,7 @@
           <a:lstStyle/>
           <a:p>
             <a:pPr algn="ctr"/>
+            <a:endParaRPr/>
           </a:p>
         </p:txBody>
       </p:sp>
@@ -11626,7 +11563,7 @@
           <a:lstStyle/>
           <a:p>
             <a:pPr>
-              <a:defRPr b="1" sz="1500">
+              <a:defRPr sz="1500" b="1">
                 <a:solidFill>
                   <a:srgbClr val="1E2761"/>
                 </a:solidFill>
@@ -11689,6 +11626,7 @@
           <a:lstStyle/>
           <a:p>
             <a:pPr algn="ctr"/>
+            <a:endParaRPr/>
           </a:p>
         </p:txBody>
       </p:sp>
@@ -11732,6 +11670,7 @@
           <a:lstStyle/>
           <a:p>
             <a:pPr algn="ctr"/>
+            <a:endParaRPr/>
           </a:p>
         </p:txBody>
       </p:sp>
@@ -11758,7 +11697,7 @@
           <a:lstStyle/>
           <a:p>
             <a:pPr>
-              <a:defRPr b="1" sz="1500">
+              <a:defRPr sz="1500" b="1">
                 <a:solidFill>
                   <a:srgbClr val="1E2761"/>
                 </a:solidFill>
@@ -11833,6 +11772,7 @@
           <a:lstStyle/>
           <a:p>
             <a:pPr algn="ctr"/>
+            <a:endParaRPr/>
           </a:p>
         </p:txBody>
       </p:sp>
@@ -11876,6 +11816,7 @@
           <a:lstStyle/>
           <a:p>
             <a:pPr algn="ctr"/>
+            <a:endParaRPr/>
           </a:p>
         </p:txBody>
       </p:sp>
@@ -11902,7 +11843,7 @@
           <a:lstStyle/>
           <a:p>
             <a:pPr>
-              <a:defRPr b="1" sz="1500">
+              <a:defRPr sz="1500" b="1">
                 <a:solidFill>
                   <a:srgbClr val="1E2761"/>
                 </a:solidFill>
@@ -11959,7 +11900,7 @@
 </file>
 
 <file path=ppt/slides/slide5.xml><?xml version="1.0" encoding="utf-8"?>
-<p:sld xmlns:a="http://schemas.openxmlformats.org/drawingml/2006/main" xmlns:p="http://schemas.openxmlformats.org/presentationml/2006/main" xmlns:r="http://schemas.openxmlformats.org/officeDocument/2006/relationships">
+<p:sld xmlns:a="http://schemas.openxmlformats.org/drawingml/2006/main" xmlns:r="http://schemas.openxmlformats.org/officeDocument/2006/relationships" xmlns:p="http://schemas.openxmlformats.org/presentationml/2006/main">
   <p:cSld>
     <p:spTree>
       <p:nvGrpSpPr>
@@ -11967,7 +11908,14 @@
         <p:cNvGrpSpPr/>
         <p:nvPr/>
       </p:nvGrpSpPr>
-      <p:grpSpPr/>
+      <p:grpSpPr>
+        <a:xfrm>
+          <a:off x="0" y="0"/>
+          <a:ext cx="0" cy="0"/>
+          <a:chOff x="0" y="0"/>
+          <a:chExt cx="0" cy="0"/>
+        </a:xfrm>
+      </p:grpSpPr>
       <p:sp>
         <p:nvSpPr>
           <p:cNvPr id="2" name="Rectangle 1"/>
@@ -12008,6 +11956,7 @@
           <a:lstStyle/>
           <a:p>
             <a:pPr algn="ctr"/>
+            <a:endParaRPr/>
           </a:p>
         </p:txBody>
       </p:sp>
@@ -12034,7 +11983,7 @@
           <a:lstStyle/>
           <a:p>
             <a:pPr>
-              <a:defRPr b="1" sz="3000">
+              <a:defRPr sz="3000" b="1">
                 <a:solidFill>
                   <a:srgbClr val="1E2761"/>
                 </a:solidFill>
@@ -12089,6 +12038,7 @@
           <a:lstStyle/>
           <a:p>
             <a:pPr algn="ctr"/>
+            <a:endParaRPr/>
           </a:p>
         </p:txBody>
       </p:sp>
@@ -12132,6 +12082,7 @@
           <a:lstStyle/>
           <a:p>
             <a:pPr algn="ctr"/>
+            <a:endParaRPr/>
           </a:p>
         </p:txBody>
       </p:sp>
@@ -12158,7 +12109,7 @@
           <a:lstStyle/>
           <a:p>
             <a:pPr>
-              <a:defRPr b="1" sz="1500">
+              <a:defRPr sz="1500" b="1">
                 <a:solidFill>
                   <a:srgbClr val="1E2761"/>
                 </a:solidFill>
@@ -12221,6 +12172,7 @@
           <a:lstStyle/>
           <a:p>
             <a:pPr algn="ctr"/>
+            <a:endParaRPr/>
           </a:p>
         </p:txBody>
       </p:sp>
@@ -12264,6 +12216,7 @@
           <a:lstStyle/>
           <a:p>
             <a:pPr algn="ctr"/>
+            <a:endParaRPr/>
           </a:p>
         </p:txBody>
       </p:sp>
@@ -12290,7 +12243,7 @@
           <a:lstStyle/>
           <a:p>
             <a:pPr>
-              <a:defRPr b="1" sz="1500">
+              <a:defRPr sz="1500" b="1">
                 <a:solidFill>
                   <a:srgbClr val="1E2761"/>
                 </a:solidFill>
@@ -12361,6 +12314,7 @@
           <a:lstStyle/>
           <a:p>
             <a:pPr algn="ctr"/>
+            <a:endParaRPr/>
           </a:p>
         </p:txBody>
       </p:sp>
@@ -12404,6 +12358,7 @@
           <a:lstStyle/>
           <a:p>
             <a:pPr algn="ctr"/>
+            <a:endParaRPr/>
           </a:p>
         </p:txBody>
       </p:sp>
@@ -12430,7 +12385,7 @@
           <a:lstStyle/>
           <a:p>
             <a:pPr>
-              <a:defRPr b="1" sz="1500">
+              <a:defRPr sz="1500" b="1">
                 <a:solidFill>
                   <a:srgbClr val="1E2761"/>
                 </a:solidFill>
@@ -12487,7 +12442,7 @@
 </file>
 
 <file path=ppt/slides/slide6.xml><?xml version="1.0" encoding="utf-8"?>
-<p:sld xmlns:a="http://schemas.openxmlformats.org/drawingml/2006/main" xmlns:p="http://schemas.openxmlformats.org/presentationml/2006/main" xmlns:r="http://schemas.openxmlformats.org/officeDocument/2006/relationships">
+<p:sld xmlns:a="http://schemas.openxmlformats.org/drawingml/2006/main" xmlns:r="http://schemas.openxmlformats.org/officeDocument/2006/relationships" xmlns:p="http://schemas.openxmlformats.org/presentationml/2006/main">
   <p:cSld>
     <p:spTree>
       <p:nvGrpSpPr>
@@ -12495,7 +12450,14 @@
         <p:cNvGrpSpPr/>
         <p:nvPr/>
       </p:nvGrpSpPr>
-      <p:grpSpPr/>
+      <p:grpSpPr>
+        <a:xfrm>
+          <a:off x="0" y="0"/>
+          <a:ext cx="0" cy="0"/>
+          <a:chOff x="0" y="0"/>
+          <a:chExt cx="0" cy="0"/>
+        </a:xfrm>
+      </p:grpSpPr>
       <p:sp>
         <p:nvSpPr>
           <p:cNvPr id="2" name="Rectangle 1"/>
@@ -12536,6 +12498,7 @@
           <a:lstStyle/>
           <a:p>
             <a:pPr algn="ctr"/>
+            <a:endParaRPr/>
           </a:p>
         </p:txBody>
       </p:sp>
@@ -12562,7 +12525,7 @@
           <a:lstStyle/>
           <a:p>
             <a:pPr>
-              <a:defRPr b="1" sz="3000">
+              <a:defRPr sz="3000" b="1">
                 <a:solidFill>
                   <a:srgbClr val="1E2761"/>
                 </a:solidFill>
@@ -12617,6 +12580,7 @@
           <a:lstStyle/>
           <a:p>
             <a:pPr algn="ctr"/>
+            <a:endParaRPr/>
           </a:p>
         </p:txBody>
       </p:sp>
@@ -12660,6 +12624,7 @@
           <a:lstStyle/>
           <a:p>
             <a:pPr algn="ctr"/>
+            <a:endParaRPr/>
           </a:p>
         </p:txBody>
       </p:sp>
@@ -12686,7 +12651,7 @@
           <a:lstStyle/>
           <a:p>
             <a:pPr>
-              <a:defRPr b="1" sz="1500">
+              <a:defRPr sz="1500" b="1">
                 <a:solidFill>
                   <a:srgbClr val="1E2761"/>
                 </a:solidFill>
@@ -12753,6 +12718,7 @@
           <a:lstStyle/>
           <a:p>
             <a:pPr algn="ctr"/>
+            <a:endParaRPr/>
           </a:p>
         </p:txBody>
       </p:sp>
@@ -12796,6 +12762,7 @@
           <a:lstStyle/>
           <a:p>
             <a:pPr algn="ctr"/>
+            <a:endParaRPr/>
           </a:p>
         </p:txBody>
       </p:sp>
@@ -12822,7 +12789,7 @@
           <a:lstStyle/>
           <a:p>
             <a:pPr>
-              <a:defRPr b="1" sz="1500">
+              <a:defRPr sz="1500" b="1">
                 <a:solidFill>
                   <a:srgbClr val="1E2761"/>
                 </a:solidFill>
@@ -12897,6 +12864,7 @@
           <a:lstStyle/>
           <a:p>
             <a:pPr algn="ctr"/>
+            <a:endParaRPr/>
           </a:p>
         </p:txBody>
       </p:sp>
@@ -12940,6 +12908,7 @@
           <a:lstStyle/>
           <a:p>
             <a:pPr algn="ctr"/>
+            <a:endParaRPr/>
           </a:p>
         </p:txBody>
       </p:sp>
@@ -12966,7 +12935,7 @@
           <a:lstStyle/>
           <a:p>
             <a:pPr>
-              <a:defRPr b="1" sz="1500">
+              <a:defRPr sz="1500" b="1">
                 <a:solidFill>
                   <a:srgbClr val="1E2761"/>
                 </a:solidFill>
@@ -13023,7 +12992,7 @@
 </file>
 
 <file path=ppt/slides/slide7.xml><?xml version="1.0" encoding="utf-8"?>
-<p:sld xmlns:a="http://schemas.openxmlformats.org/drawingml/2006/main" xmlns:p="http://schemas.openxmlformats.org/presentationml/2006/main" xmlns:r="http://schemas.openxmlformats.org/officeDocument/2006/relationships">
+<p:sld xmlns:a="http://schemas.openxmlformats.org/drawingml/2006/main" xmlns:r="http://schemas.openxmlformats.org/officeDocument/2006/relationships" xmlns:p="http://schemas.openxmlformats.org/presentationml/2006/main">
   <p:cSld>
     <p:spTree>
       <p:nvGrpSpPr>
@@ -13031,7 +13000,14 @@
         <p:cNvGrpSpPr/>
         <p:nvPr/>
       </p:nvGrpSpPr>
-      <p:grpSpPr/>
+      <p:grpSpPr>
+        <a:xfrm>
+          <a:off x="0" y="0"/>
+          <a:ext cx="0" cy="0"/>
+          <a:chOff x="0" y="0"/>
+          <a:chExt cx="0" cy="0"/>
+        </a:xfrm>
+      </p:grpSpPr>
       <p:sp>
         <p:nvSpPr>
           <p:cNvPr id="2" name="Rectangle 1"/>
@@ -13072,6 +13048,7 @@
           <a:lstStyle/>
           <a:p>
             <a:pPr algn="ctr"/>
+            <a:endParaRPr/>
           </a:p>
         </p:txBody>
       </p:sp>
@@ -13098,7 +13075,7 @@
           <a:lstStyle/>
           <a:p>
             <a:pPr>
-              <a:defRPr b="1" sz="3000">
+              <a:defRPr sz="3000" b="1">
                 <a:solidFill>
                   <a:srgbClr val="1E2761"/>
                 </a:solidFill>
@@ -13153,6 +13130,7 @@
           <a:lstStyle/>
           <a:p>
             <a:pPr algn="ctr"/>
+            <a:endParaRPr/>
           </a:p>
         </p:txBody>
       </p:sp>
@@ -13196,6 +13174,7 @@
           <a:lstStyle/>
           <a:p>
             <a:pPr algn="ctr"/>
+            <a:endParaRPr/>
           </a:p>
         </p:txBody>
       </p:sp>
@@ -13222,7 +13201,7 @@
           <a:lstStyle/>
           <a:p>
             <a:pPr>
-              <a:defRPr b="1" sz="1500">
+              <a:defRPr sz="1500" b="1">
                 <a:solidFill>
                   <a:srgbClr val="1E2761"/>
                 </a:solidFill>
@@ -13285,6 +13264,7 @@
           <a:lstStyle/>
           <a:p>
             <a:pPr algn="ctr"/>
+            <a:endParaRPr/>
           </a:p>
         </p:txBody>
       </p:sp>
@@ -13328,6 +13308,7 @@
           <a:lstStyle/>
           <a:p>
             <a:pPr algn="ctr"/>
+            <a:endParaRPr/>
           </a:p>
         </p:txBody>
       </p:sp>
@@ -13354,7 +13335,7 @@
           <a:lstStyle/>
           <a:p>
             <a:pPr>
-              <a:defRPr b="1" sz="1500">
+              <a:defRPr sz="1500" b="1">
                 <a:solidFill>
                   <a:srgbClr val="1E2761"/>
                 </a:solidFill>
@@ -13429,6 +13410,7 @@
           <a:lstStyle/>
           <a:p>
             <a:pPr algn="ctr"/>
+            <a:endParaRPr/>
           </a:p>
         </p:txBody>
       </p:sp>
@@ -13472,6 +13454,7 @@
           <a:lstStyle/>
           <a:p>
             <a:pPr algn="ctr"/>
+            <a:endParaRPr/>
           </a:p>
         </p:txBody>
       </p:sp>
@@ -13498,7 +13481,7 @@
           <a:lstStyle/>
           <a:p>
             <a:pPr>
-              <a:defRPr b="1" sz="1500">
+              <a:defRPr sz="1500" b="1">
                 <a:solidFill>
                   <a:srgbClr val="1E2761"/>
                 </a:solidFill>
@@ -13555,7 +13538,7 @@
 </file>
 
 <file path=ppt/slides/slide8.xml><?xml version="1.0" encoding="utf-8"?>
-<p:sld xmlns:a="http://schemas.openxmlformats.org/drawingml/2006/main" xmlns:p="http://schemas.openxmlformats.org/presentationml/2006/main" xmlns:r="http://schemas.openxmlformats.org/officeDocument/2006/relationships">
+<p:sld xmlns:a="http://schemas.openxmlformats.org/drawingml/2006/main" xmlns:r="http://schemas.openxmlformats.org/officeDocument/2006/relationships" xmlns:p="http://schemas.openxmlformats.org/presentationml/2006/main">
   <p:cSld>
     <p:spTree>
       <p:nvGrpSpPr>
@@ -13563,7 +13546,14 @@
         <p:cNvGrpSpPr/>
         <p:nvPr/>
       </p:nvGrpSpPr>
-      <p:grpSpPr/>
+      <p:grpSpPr>
+        <a:xfrm>
+          <a:off x="0" y="0"/>
+          <a:ext cx="0" cy="0"/>
+          <a:chOff x="0" y="0"/>
+          <a:chExt cx="0" cy="0"/>
+        </a:xfrm>
+      </p:grpSpPr>
       <p:sp>
         <p:nvSpPr>
           <p:cNvPr id="2" name="Rectangle 1"/>
@@ -13604,6 +13594,7 @@
           <a:lstStyle/>
           <a:p>
             <a:pPr algn="ctr"/>
+            <a:endParaRPr/>
           </a:p>
         </p:txBody>
       </p:sp>
@@ -13630,7 +13621,7 @@
           <a:lstStyle/>
           <a:p>
             <a:pPr>
-              <a:defRPr b="1" sz="3000">
+              <a:defRPr sz="3000" b="1">
                 <a:solidFill>
                   <a:srgbClr val="1E2761"/>
                 </a:solidFill>
@@ -13685,6 +13676,7 @@
           <a:lstStyle/>
           <a:p>
             <a:pPr algn="ctr"/>
+            <a:endParaRPr/>
           </a:p>
         </p:txBody>
       </p:sp>
@@ -13728,6 +13720,7 @@
           <a:lstStyle/>
           <a:p>
             <a:pPr algn="ctr"/>
+            <a:endParaRPr/>
           </a:p>
         </p:txBody>
       </p:sp>
@@ -13754,7 +13747,7 @@
           <a:lstStyle/>
           <a:p>
             <a:pPr>
-              <a:defRPr b="1" sz="1500">
+              <a:defRPr sz="1500" b="1">
                 <a:solidFill>
                   <a:srgbClr val="1E2761"/>
                 </a:solidFill>
@@ -13821,6 +13814,7 @@
           <a:lstStyle/>
           <a:p>
             <a:pPr algn="ctr"/>
+            <a:endParaRPr/>
           </a:p>
         </p:txBody>
       </p:sp>
@@ -13864,6 +13858,7 @@
           <a:lstStyle/>
           <a:p>
             <a:pPr algn="ctr"/>
+            <a:endParaRPr/>
           </a:p>
         </p:txBody>
       </p:sp>
@@ -13890,7 +13885,7 @@
           <a:lstStyle/>
           <a:p>
             <a:pPr>
-              <a:defRPr b="1" sz="1500">
+              <a:defRPr sz="1500" b="1">
                 <a:solidFill>
                   <a:srgbClr val="1E2761"/>
                 </a:solidFill>
@@ -13965,6 +13960,7 @@
           <a:lstStyle/>
           <a:p>
             <a:pPr algn="ctr"/>
+            <a:endParaRPr/>
           </a:p>
         </p:txBody>
       </p:sp>
@@ -14008,6 +14004,7 @@
           <a:lstStyle/>
           <a:p>
             <a:pPr algn="ctr"/>
+            <a:endParaRPr/>
           </a:p>
         </p:txBody>
       </p:sp>
@@ -14034,7 +14031,7 @@
           <a:lstStyle/>
           <a:p>
             <a:pPr>
-              <a:defRPr b="1" sz="1500">
+              <a:defRPr sz="1500" b="1">
                 <a:solidFill>
                   <a:srgbClr val="1E2761"/>
                 </a:solidFill>
@@ -14091,7 +14088,7 @@
 </file>
 
 <file path=ppt/slides/slide9.xml><?xml version="1.0" encoding="utf-8"?>
-<p:sld xmlns:a="http://schemas.openxmlformats.org/drawingml/2006/main" xmlns:p="http://schemas.openxmlformats.org/presentationml/2006/main" xmlns:r="http://schemas.openxmlformats.org/officeDocument/2006/relationships">
+<p:sld xmlns:a="http://schemas.openxmlformats.org/drawingml/2006/main" xmlns:r="http://schemas.openxmlformats.org/officeDocument/2006/relationships" xmlns:p="http://schemas.openxmlformats.org/presentationml/2006/main">
   <p:cSld>
     <p:spTree>
       <p:nvGrpSpPr>
@@ -14099,7 +14096,14 @@
         <p:cNvGrpSpPr/>
         <p:nvPr/>
       </p:nvGrpSpPr>
-      <p:grpSpPr/>
+      <p:grpSpPr>
+        <a:xfrm>
+          <a:off x="0" y="0"/>
+          <a:ext cx="0" cy="0"/>
+          <a:chOff x="0" y="0"/>
+          <a:chExt cx="0" cy="0"/>
+        </a:xfrm>
+      </p:grpSpPr>
       <p:sp>
         <p:nvSpPr>
           <p:cNvPr id="2" name="Rectangle 1"/>
@@ -14140,6 +14144,7 @@
           <a:lstStyle/>
           <a:p>
             <a:pPr algn="ctr"/>
+            <a:endParaRPr/>
           </a:p>
         </p:txBody>
       </p:sp>
@@ -14166,7 +14171,7 @@
           <a:lstStyle/>
           <a:p>
             <a:pPr>
-              <a:defRPr b="1" sz="3000">
+              <a:defRPr sz="3000" b="1">
                 <a:solidFill>
                   <a:srgbClr val="1E2761"/>
                 </a:solidFill>
@@ -14221,6 +14226,7 @@
           <a:lstStyle/>
           <a:p>
             <a:pPr algn="ctr"/>
+            <a:endParaRPr/>
           </a:p>
         </p:txBody>
       </p:sp>
@@ -14264,6 +14270,7 @@
           <a:lstStyle/>
           <a:p>
             <a:pPr algn="ctr"/>
+            <a:endParaRPr/>
           </a:p>
         </p:txBody>
       </p:sp>
@@ -14290,7 +14297,7 @@
           <a:lstStyle/>
           <a:p>
             <a:pPr>
-              <a:defRPr b="1" sz="1500">
+              <a:defRPr sz="1500" b="1">
                 <a:solidFill>
                   <a:srgbClr val="1E2761"/>
                 </a:solidFill>
@@ -14353,6 +14360,7 @@
           <a:lstStyle/>
           <a:p>
             <a:pPr algn="ctr"/>
+            <a:endParaRPr/>
           </a:p>
         </p:txBody>
       </p:sp>
@@ -14396,6 +14404,7 @@
           <a:lstStyle/>
           <a:p>
             <a:pPr algn="ctr"/>
+            <a:endParaRPr/>
           </a:p>
         </p:txBody>
       </p:sp>
@@ -14422,7 +14431,7 @@
           <a:lstStyle/>
           <a:p>
             <a:pPr>
-              <a:defRPr b="1" sz="1500">
+              <a:defRPr sz="1500" b="1">
                 <a:solidFill>
                   <a:srgbClr val="1E2761"/>
                 </a:solidFill>
@@ -14493,6 +14502,7 @@
           <a:lstStyle/>
           <a:p>
             <a:pPr algn="ctr"/>
+            <a:endParaRPr/>
           </a:p>
         </p:txBody>
       </p:sp>
@@ -14536,6 +14546,7 @@
           <a:lstStyle/>
           <a:p>
             <a:pPr algn="ctr"/>
+            <a:endParaRPr/>
           </a:p>
         </p:txBody>
       </p:sp>
@@ -14562,7 +14573,7 @@
           <a:lstStyle/>
           <a:p>
             <a:pPr>
-              <a:defRPr b="1" sz="1500">
+              <a:defRPr sz="1500" b="1">
                 <a:solidFill>
                   <a:srgbClr val="1E2761"/>
                 </a:solidFill>
@@ -14949,44 +14960,44 @@
         <a:sysClr val="window" lastClr="FFFFFF"/>
       </a:lt1>
       <a:dk2>
-        <a:srgbClr val="1F497D"/>
+        <a:srgbClr val="0E2841"/>
       </a:dk2>
       <a:lt2>
-        <a:srgbClr val="EEECE1"/>
+        <a:srgbClr val="E8E8E8"/>
       </a:lt2>
       <a:accent1>
-        <a:srgbClr val="4F81BD"/>
+        <a:srgbClr val="156082"/>
       </a:accent1>
       <a:accent2>
-        <a:srgbClr val="C0504D"/>
+        <a:srgbClr val="E97132"/>
       </a:accent2>
       <a:accent3>
-        <a:srgbClr val="9BBB59"/>
+        <a:srgbClr val="196B24"/>
       </a:accent3>
       <a:accent4>
-        <a:srgbClr val="8064A2"/>
+        <a:srgbClr val="0F9ED5"/>
       </a:accent4>
       <a:accent5>
-        <a:srgbClr val="4BACC6"/>
+        <a:srgbClr val="A02B93"/>
       </a:accent5>
       <a:accent6>
-        <a:srgbClr val="F79646"/>
+        <a:srgbClr val="4EA72E"/>
       </a:accent6>
       <a:hlink>
-        <a:srgbClr val="0000FF"/>
+        <a:srgbClr val="467886"/>
       </a:hlink>
       <a:folHlink>
-        <a:srgbClr val="800080"/>
+        <a:srgbClr val="96607D"/>
       </a:folHlink>
     </a:clrScheme>
     <a:fontScheme name="Office">
       <a:majorFont>
-        <a:latin typeface="Calibri"/>
+        <a:latin typeface="Aptos Display" panose="02110004020202020204"/>
         <a:ea typeface=""/>
         <a:cs typeface=""/>
-        <a:font script="Jpan" typeface="ＭＳ Ｐゴシック"/>
+        <a:font script="Jpan" typeface="游ゴシック Light"/>
         <a:font script="Hang" typeface="맑은 고딕"/>
-        <a:font script="Hans" typeface="宋体"/>
+        <a:font script="Hans" typeface="等线 Light"/>
         <a:font script="Hant" typeface="新細明體"/>
         <a:font script="Arab" typeface="Times New Roman"/>
         <a:font script="Hebr" typeface="Times New Roman"/>
@@ -15014,14 +15025,31 @@
         <a:font script="Viet" typeface="Times New Roman"/>
         <a:font script="Uigh" typeface="Microsoft Uighur"/>
         <a:font script="Geor" typeface="Sylfaen"/>
+        <a:font script="Armn" typeface="Arial"/>
+        <a:font script="Bugi" typeface="Leelawadee UI"/>
+        <a:font script="Bopo" typeface="Microsoft JhengHei"/>
+        <a:font script="Java" typeface="Javanese Text"/>
+        <a:font script="Lisu" typeface="Segoe UI"/>
+        <a:font script="Mymr" typeface="Myanmar Text"/>
+        <a:font script="Nkoo" typeface="Ebrima"/>
+        <a:font script="Olck" typeface="Nirmala UI"/>
+        <a:font script="Osma" typeface="Ebrima"/>
+        <a:font script="Phag" typeface="Phagspa"/>
+        <a:font script="Syrn" typeface="Estrangelo Edessa"/>
+        <a:font script="Syrj" typeface="Estrangelo Edessa"/>
+        <a:font script="Syre" typeface="Estrangelo Edessa"/>
+        <a:font script="Sora" typeface="Nirmala UI"/>
+        <a:font script="Tale" typeface="Microsoft Tai Le"/>
+        <a:font script="Talu" typeface="Microsoft New Tai Lue"/>
+        <a:font script="Tfng" typeface="Ebrima"/>
       </a:majorFont>
       <a:minorFont>
-        <a:latin typeface="Calibri"/>
+        <a:latin typeface="Aptos" panose="02110004020202020204"/>
         <a:ea typeface=""/>
         <a:cs typeface=""/>
-        <a:font script="Jpan" typeface="ＭＳ Ｐゴシック"/>
+        <a:font script="Jpan" typeface="游ゴシック"/>
         <a:font script="Hang" typeface="맑은 고딕"/>
-        <a:font script="Hans" typeface="宋体"/>
+        <a:font script="Hans" typeface="等线"/>
         <a:font script="Hant" typeface="新細明體"/>
         <a:font script="Arab" typeface="Arial"/>
         <a:font script="Hebr" typeface="Arial"/>
@@ -15049,6 +15077,23 @@
         <a:font script="Viet" typeface="Arial"/>
         <a:font script="Uigh" typeface="Microsoft Uighur"/>
         <a:font script="Geor" typeface="Sylfaen"/>
+        <a:font script="Armn" typeface="Arial"/>
+        <a:font script="Bugi" typeface="Leelawadee UI"/>
+        <a:font script="Bopo" typeface="Microsoft JhengHei"/>
+        <a:font script="Java" typeface="Javanese Text"/>
+        <a:font script="Lisu" typeface="Segoe UI"/>
+        <a:font script="Mymr" typeface="Myanmar Text"/>
+        <a:font script="Nkoo" typeface="Ebrima"/>
+        <a:font script="Olck" typeface="Nirmala UI"/>
+        <a:font script="Osma" typeface="Ebrima"/>
+        <a:font script="Phag" typeface="Phagspa"/>
+        <a:font script="Syrn" typeface="Estrangelo Edessa"/>
+        <a:font script="Syrj" typeface="Estrangelo Edessa"/>
+        <a:font script="Syre" typeface="Estrangelo Edessa"/>
+        <a:font script="Sora" typeface="Nirmala UI"/>
+        <a:font script="Tale" typeface="Microsoft Tai Le"/>
+        <a:font script="Talu" typeface="Microsoft New Tai Lue"/>
+        <a:font script="Tfng" typeface="Ebrima"/>
       </a:minorFont>
     </a:fontScheme>
     <a:fmtScheme name="Office">
@@ -15060,180 +15105,136 @@
           <a:gsLst>
             <a:gs pos="0">
               <a:schemeClr val="phClr">
-                <a:tint val="50000"/>
-                <a:satMod val="300000"/>
+                <a:lumMod val="110000"/>
+                <a:satMod val="105000"/>
+                <a:tint val="67000"/>
               </a:schemeClr>
             </a:gs>
-            <a:gs pos="35000">
+            <a:gs pos="50000">
               <a:schemeClr val="phClr">
-                <a:tint val="37000"/>
-                <a:satMod val="300000"/>
+                <a:lumMod val="105000"/>
+                <a:satMod val="103000"/>
+                <a:tint val="73000"/>
               </a:schemeClr>
             </a:gs>
             <a:gs pos="100000">
               <a:schemeClr val="phClr">
-                <a:tint val="15000"/>
-                <a:satMod val="350000"/>
+                <a:lumMod val="105000"/>
+                <a:satMod val="109000"/>
+                <a:tint val="81000"/>
               </a:schemeClr>
             </a:gs>
           </a:gsLst>
-          <a:lin ang="16200000" scaled="1"/>
+          <a:lin ang="5400000" scaled="0"/>
         </a:gradFill>
         <a:gradFill rotWithShape="1">
           <a:gsLst>
             <a:gs pos="0">
               <a:schemeClr val="phClr">
-                <a:tint val="100000"/>
+                <a:satMod val="103000"/>
+                <a:lumMod val="102000"/>
+                <a:tint val="94000"/>
+              </a:schemeClr>
+            </a:gs>
+            <a:gs pos="50000">
+              <a:schemeClr val="phClr">
+                <a:satMod val="110000"/>
+                <a:lumMod val="100000"/>
                 <a:shade val="100000"/>
-                <a:satMod val="130000"/>
               </a:schemeClr>
             </a:gs>
             <a:gs pos="100000">
               <a:schemeClr val="phClr">
-                <a:tint val="50000"/>
-                <a:shade val="100000"/>
-                <a:satMod val="350000"/>
+                <a:lumMod val="99000"/>
+                <a:satMod val="120000"/>
+                <a:shade val="78000"/>
               </a:schemeClr>
             </a:gs>
           </a:gsLst>
-          <a:lin ang="16200000" scaled="0"/>
+          <a:lin ang="5400000" scaled="0"/>
         </a:gradFill>
       </a:fillStyleLst>
       <a:lnStyleLst>
-        <a:ln w="9525" cap="flat" cmpd="sng" algn="ctr">
+        <a:ln w="12700" cap="flat" cmpd="sng" algn="ctr">
           <a:solidFill>
-            <a:schemeClr val="phClr">
-              <a:shade val="95000"/>
-              <a:satMod val="105000"/>
-            </a:schemeClr>
+            <a:schemeClr val="phClr"/>
           </a:solidFill>
           <a:prstDash val="solid"/>
+          <a:miter lim="800000"/>
+        </a:ln>
+        <a:ln w="19050" cap="flat" cmpd="sng" algn="ctr">
+          <a:solidFill>
+            <a:schemeClr val="phClr"/>
+          </a:solidFill>
+          <a:prstDash val="solid"/>
+          <a:miter lim="800000"/>
         </a:ln>
         <a:ln w="25400" cap="flat" cmpd="sng" algn="ctr">
           <a:solidFill>
             <a:schemeClr val="phClr"/>
           </a:solidFill>
           <a:prstDash val="solid"/>
-        </a:ln>
-        <a:ln w="38100" cap="flat" cmpd="sng" algn="ctr">
-          <a:solidFill>
-            <a:schemeClr val="phClr"/>
-          </a:solidFill>
-          <a:prstDash val="solid"/>
+          <a:miter lim="800000"/>
         </a:ln>
       </a:lnStyleLst>
       <a:effectStyleLst>
         <a:effectStyle>
+          <a:effectLst/>
+        </a:effectStyle>
+        <a:effectStyle>
+          <a:effectLst/>
+        </a:effectStyle>
+        <a:effectStyle>
           <a:effectLst>
-            <a:outerShdw blurRad="40000" dist="20000" dir="5400000" rotWithShape="0">
+            <a:outerShdw blurRad="57150" dist="19050" dir="5400000" algn="ctr" rotWithShape="0">
               <a:srgbClr val="000000">
-                <a:alpha val="38000"/>
+                <a:alpha val="63000"/>
               </a:srgbClr>
             </a:outerShdw>
           </a:effectLst>
-        </a:effectStyle>
-        <a:effectStyle>
-          <a:effectLst>
-            <a:outerShdw blurRad="40000" dist="23000" dir="5400000" rotWithShape="0">
-              <a:srgbClr val="000000">
-                <a:alpha val="35000"/>
-              </a:srgbClr>
-            </a:outerShdw>
-          </a:effectLst>
-        </a:effectStyle>
-        <a:effectStyle>
-          <a:effectLst>
-            <a:outerShdw blurRad="40000" dist="23000" dir="5400000" rotWithShape="0">
-              <a:srgbClr val="000000">
-                <a:alpha val="35000"/>
-              </a:srgbClr>
-            </a:outerShdw>
-          </a:effectLst>
-          <a:scene3d>
-            <a:camera prst="orthographicFront">
-              <a:rot lat="0" lon="0" rev="0"/>
-            </a:camera>
-            <a:lightRig rig="threePt" dir="t">
-              <a:rot lat="0" lon="0" rev="1200000"/>
-            </a:lightRig>
-          </a:scene3d>
-          <a:sp3d>
-            <a:bevelT w="63500" h="25400"/>
-          </a:sp3d>
         </a:effectStyle>
       </a:effectStyleLst>
       <a:bgFillStyleLst>
         <a:solidFill>
           <a:schemeClr val="phClr"/>
         </a:solidFill>
+        <a:solidFill>
+          <a:schemeClr val="phClr">
+            <a:tint val="95000"/>
+            <a:satMod val="170000"/>
+          </a:schemeClr>
+        </a:solidFill>
         <a:gradFill rotWithShape="1">
           <a:gsLst>
             <a:gs pos="0">
               <a:schemeClr val="phClr">
-                <a:tint val="40000"/>
-                <a:satMod val="350000"/>
+                <a:tint val="93000"/>
+                <a:satMod val="150000"/>
+                <a:shade val="98000"/>
+                <a:lumMod val="102000"/>
               </a:schemeClr>
             </a:gs>
-            <a:gs pos="40000">
+            <a:gs pos="50000">
               <a:schemeClr val="phClr">
-                <a:tint val="45000"/>
-                <a:shade val="99000"/>
-                <a:satMod val="350000"/>
+                <a:tint val="98000"/>
+                <a:satMod val="130000"/>
+                <a:shade val="90000"/>
+                <a:lumMod val="103000"/>
               </a:schemeClr>
             </a:gs>
             <a:gs pos="100000">
               <a:schemeClr val="phClr">
-                <a:shade val="20000"/>
-                <a:satMod val="255000"/>
+                <a:shade val="63000"/>
+                <a:satMod val="120000"/>
               </a:schemeClr>
             </a:gs>
           </a:gsLst>
-          <a:path path="circle">
-            <a:fillToRect l="50000" t="-80000" r="50000" b="180000"/>
-          </a:path>
-        </a:gradFill>
-        <a:gradFill rotWithShape="1">
-          <a:gsLst>
-            <a:gs pos="0">
-              <a:schemeClr val="phClr">
-                <a:tint val="80000"/>
-                <a:satMod val="300000"/>
-              </a:schemeClr>
-            </a:gs>
-            <a:gs pos="100000">
-              <a:schemeClr val="phClr">
-                <a:shade val="30000"/>
-                <a:satMod val="200000"/>
-              </a:schemeClr>
-            </a:gs>
-          </a:gsLst>
-          <a:path path="circle">
-            <a:fillToRect l="50000" t="50000" r="50000" b="50000"/>
-          </a:path>
+          <a:lin ang="5400000" scaled="0"/>
         </a:gradFill>
       </a:bgFillStyleLst>
     </a:fmtScheme>
   </a:themeElements>
   <a:objectDefaults>
-    <a:spDef>
-      <a:spPr/>
-      <a:bodyPr/>
-      <a:lstStyle/>
-      <a:style>
-        <a:lnRef idx="1">
-          <a:schemeClr val="accent1"/>
-        </a:lnRef>
-        <a:fillRef idx="3">
-          <a:schemeClr val="accent1"/>
-        </a:fillRef>
-        <a:effectRef idx="2">
-          <a:schemeClr val="accent1"/>
-        </a:effectRef>
-        <a:fontRef idx="minor">
-          <a:schemeClr val="lt1"/>
-        </a:fontRef>
-      </a:style>
-    </a:spDef>
     <a:lnDef>
       <a:spPr/>
       <a:bodyPr/>
@@ -15255,5 +15256,16 @@
     </a:lnDef>
   </a:objectDefaults>
   <a:extraClrSchemeLst/>
+  <a:extLst>
+    <a:ext uri="{05A4C25C-085E-4340-85A3-A5531E510DB2}">
+      <thm15:themeFamily xmlns:thm15="http://schemas.microsoft.com/office/thememl/2012/main" name="Office Theme" id="{2E142A2C-CD16-42D6-873A-C26D2A0506FA}" vid="{1BDDFF52-6CD6-40A5-AB3C-68EB2F1E4D0A}"/>
+    </a:ext>
+  </a:extLst>
 </a:theme>
+</file>
+
+<file path=docMetadata/LabelInfo.xml><?xml version="1.0" encoding="utf-8"?>
+<clbl:labelList xmlns:clbl="http://schemas.microsoft.com/office/2020/mipLabelMetadata">
+  <clbl:label id="{f42aa342-8706-4288-bd11-ebb85995028c}" enabled="1" method="Standard" siteId="{72f988bf-86f1-41af-91ab-2d7cd011db47}" contentBits="0" removed="0"/>
+</clbl:labelList>
 </file>
</xml_diff>